<commit_message>
Fixes ezrsurvey Split ai features ezrintelligence
</commit_message>
<xml_diff>
--- a/ezr-survey/inst/templates/ezrsurvey-16x9-plain.pptx
+++ b/ezr-survey/inst/templates/ezrsurvey-16x9-plain.pptx
@@ -141,8 +141,14 @@
           </a:xfrm>
         </p:spPr>
         <p:txBody>
-          <a:bodyPr/>
-          <a:lstStyle/>
+          <a:bodyPr>
+            <a:normAutofit xmlns:a="http://schemas.openxmlformats.org/drawingml/2006/main"/>
+          </a:bodyPr>
+          <a:lstStyle>
+            <a:lvl1pPr xmlns:a="http://schemas.openxmlformats.org/drawingml/2006/main" algn="l">
+              <a:defRPr xmlns:a="http://schemas.openxmlformats.org/drawingml/2006/main" sz="4000" b="1"/>
+            </a:lvl1pPr>
+          </a:lstStyle>
           <a:p>
             <a:r>
               <a:rPr lang="en-US" smtClean="0"/>
@@ -169,11 +175,13 @@
           </a:xfrm>
         </p:spPr>
         <p:txBody>
-          <a:bodyPr/>
+          <a:bodyPr>
+            <a:normAutofit xmlns:a="http://schemas.openxmlformats.org/drawingml/2006/main"/>
+          </a:bodyPr>
           <a:lstStyle>
-            <a:lvl1pPr marL="0" indent="0" algn="ctr">
-              <a:buNone/>
-              <a:defRPr>
+            <a:lvl1pPr marL="0" indent="0" algn="l">
+              <a:buNone/>
+              <a:defRPr sz="1800">
                 <a:solidFill>
                   <a:schemeClr val="tx1">
                     <a:tint val="75000"/>
@@ -283,7 +291,9 @@
         </p:nvSpPr>
         <p:spPr/>
         <p:txBody>
-          <a:bodyPr/>
+          <a:bodyPr>
+            <a:normAutofit xmlns:a="http://schemas.openxmlformats.org/drawingml/2006/main"/>
+          </a:bodyPr>
           <a:lstStyle/>
           <a:p>
             <a:fld id="{E6744CE3-0875-4B69-89C0-6F72D8139561}" type="datetimeFigureOut">
@@ -306,7 +316,9 @@
         </p:nvSpPr>
         <p:spPr/>
         <p:txBody>
-          <a:bodyPr/>
+          <a:bodyPr>
+            <a:normAutofit xmlns:a="http://schemas.openxmlformats.org/drawingml/2006/main"/>
+          </a:bodyPr>
           <a:lstStyle/>
           <a:p>
             <a:endParaRPr lang="en-GB"/>
@@ -325,7 +337,9 @@
         </p:nvSpPr>
         <p:spPr/>
         <p:txBody>
-          <a:bodyPr/>
+          <a:bodyPr>
+            <a:normAutofit xmlns:a="http://schemas.openxmlformats.org/drawingml/2006/main"/>
+          </a:bodyPr>
           <a:lstStyle/>
           <a:p>
             <a:fld id="{8DADB20D-508E-4C6D-A9E4-257D5607B0F6}" type="slidenum">
@@ -378,7 +392,9 @@
         </p:nvSpPr>
         <p:spPr/>
         <p:txBody>
-          <a:bodyPr/>
+          <a:bodyPr>
+            <a:normAutofit xmlns:a="http://schemas.openxmlformats.org/drawingml/2006/main"/>
+          </a:bodyPr>
           <a:lstStyle/>
           <a:p>
             <a:r>
@@ -401,7 +417,9 @@
         </p:nvSpPr>
         <p:spPr/>
         <p:txBody>
-          <a:bodyPr/>
+          <a:bodyPr>
+            <a:normAutofit xmlns:a="http://schemas.openxmlformats.org/drawingml/2006/main"/>
+          </a:bodyPr>
           <a:lstStyle/>
           <a:p>
             <a:pPr lvl="0"/>
@@ -453,7 +471,9 @@
         </p:nvSpPr>
         <p:spPr/>
         <p:txBody>
-          <a:bodyPr/>
+          <a:bodyPr>
+            <a:normAutofit xmlns:a="http://schemas.openxmlformats.org/drawingml/2006/main"/>
+          </a:bodyPr>
           <a:lstStyle/>
           <a:p>
             <a:fld id="{E6744CE3-0875-4B69-89C0-6F72D8139561}" type="datetimeFigureOut">
@@ -476,7 +496,9 @@
         </p:nvSpPr>
         <p:spPr/>
         <p:txBody>
-          <a:bodyPr/>
+          <a:bodyPr>
+            <a:normAutofit xmlns:a="http://schemas.openxmlformats.org/drawingml/2006/main"/>
+          </a:bodyPr>
           <a:lstStyle/>
           <a:p>
             <a:endParaRPr lang="en-GB"/>
@@ -495,7 +517,9 @@
         </p:nvSpPr>
         <p:spPr/>
         <p:txBody>
-          <a:bodyPr/>
+          <a:bodyPr>
+            <a:normAutofit xmlns:a="http://schemas.openxmlformats.org/drawingml/2006/main"/>
+          </a:bodyPr>
           <a:lstStyle/>
           <a:p>
             <a:fld id="{8DADB20D-508E-4C6D-A9E4-257D5607B0F6}" type="slidenum">
@@ -553,7 +577,9 @@
           </a:xfrm>
         </p:spPr>
         <p:txBody>
-          <a:bodyPr anchor="t"/>
+          <a:bodyPr anchor="t">
+            <a:normAutofit xmlns:a="http://schemas.openxmlformats.org/drawingml/2006/main"/>
+          </a:bodyPr>
           <a:lstStyle>
             <a:lvl1pPr algn="l">
               <a:defRPr sz="4000" b="1" cap="all"/>
@@ -585,7 +611,9 @@
           </a:xfrm>
         </p:spPr>
         <p:txBody>
-          <a:bodyPr anchor="b"/>
+          <a:bodyPr anchor="b">
+            <a:normAutofit xmlns:a="http://schemas.openxmlformats.org/drawingml/2006/main"/>
+          </a:bodyPr>
           <a:lstStyle>
             <a:lvl1pPr marL="0" indent="0">
               <a:buNone/>
@@ -699,7 +727,9 @@
         </p:nvSpPr>
         <p:spPr/>
         <p:txBody>
-          <a:bodyPr/>
+          <a:bodyPr>
+            <a:normAutofit xmlns:a="http://schemas.openxmlformats.org/drawingml/2006/main"/>
+          </a:bodyPr>
           <a:lstStyle/>
           <a:p>
             <a:fld id="{E6744CE3-0875-4B69-89C0-6F72D8139561}" type="datetimeFigureOut">
@@ -722,7 +752,9 @@
         </p:nvSpPr>
         <p:spPr/>
         <p:txBody>
-          <a:bodyPr/>
+          <a:bodyPr>
+            <a:normAutofit xmlns:a="http://schemas.openxmlformats.org/drawingml/2006/main"/>
+          </a:bodyPr>
           <a:lstStyle/>
           <a:p>
             <a:endParaRPr lang="en-GB"/>
@@ -741,7 +773,9 @@
         </p:nvSpPr>
         <p:spPr/>
         <p:txBody>
-          <a:bodyPr/>
+          <a:bodyPr>
+            <a:normAutofit xmlns:a="http://schemas.openxmlformats.org/drawingml/2006/main"/>
+          </a:bodyPr>
           <a:lstStyle/>
           <a:p>
             <a:fld id="{8DADB20D-508E-4C6D-A9E4-257D5607B0F6}" type="slidenum">
@@ -794,7 +828,9 @@
         </p:nvSpPr>
         <p:spPr/>
         <p:txBody>
-          <a:bodyPr/>
+          <a:bodyPr>
+            <a:normAutofit xmlns:a="http://schemas.openxmlformats.org/drawingml/2006/main"/>
+          </a:bodyPr>
           <a:lstStyle/>
           <a:p>
             <a:r>
@@ -822,7 +858,9 @@
           </a:xfrm>
         </p:spPr>
         <p:txBody>
-          <a:bodyPr/>
+          <a:bodyPr>
+            <a:normAutofit xmlns:a="http://schemas.openxmlformats.org/drawingml/2006/main"/>
+          </a:bodyPr>
           <a:lstStyle>
             <a:lvl1pPr>
               <a:defRPr sz="2800"/>
@@ -907,7 +945,9 @@
           </a:xfrm>
         </p:spPr>
         <p:txBody>
-          <a:bodyPr/>
+          <a:bodyPr>
+            <a:normAutofit xmlns:a="http://schemas.openxmlformats.org/drawingml/2006/main"/>
+          </a:bodyPr>
           <a:lstStyle>
             <a:lvl1pPr>
               <a:defRPr sz="2800"/>
@@ -987,7 +1027,9 @@
         </p:nvSpPr>
         <p:spPr/>
         <p:txBody>
-          <a:bodyPr/>
+          <a:bodyPr>
+            <a:normAutofit xmlns:a="http://schemas.openxmlformats.org/drawingml/2006/main"/>
+          </a:bodyPr>
           <a:lstStyle/>
           <a:p>
             <a:fld id="{E6744CE3-0875-4B69-89C0-6F72D8139561}" type="datetimeFigureOut">
@@ -1010,7 +1052,9 @@
         </p:nvSpPr>
         <p:spPr/>
         <p:txBody>
-          <a:bodyPr/>
+          <a:bodyPr>
+            <a:normAutofit xmlns:a="http://schemas.openxmlformats.org/drawingml/2006/main"/>
+          </a:bodyPr>
           <a:lstStyle/>
           <a:p>
             <a:endParaRPr lang="en-GB"/>
@@ -1029,7 +1073,9 @@
         </p:nvSpPr>
         <p:spPr/>
         <p:txBody>
-          <a:bodyPr/>
+          <a:bodyPr>
+            <a:normAutofit xmlns:a="http://schemas.openxmlformats.org/drawingml/2006/main"/>
+          </a:bodyPr>
           <a:lstStyle/>
           <a:p>
             <a:fld id="{8DADB20D-508E-4C6D-A9E4-257D5607B0F6}" type="slidenum">
@@ -1082,7 +1128,9 @@
         </p:nvSpPr>
         <p:spPr/>
         <p:txBody>
-          <a:bodyPr/>
+          <a:bodyPr>
+            <a:normAutofit xmlns:a="http://schemas.openxmlformats.org/drawingml/2006/main"/>
+          </a:bodyPr>
           <a:lstStyle>
             <a:lvl1pPr>
               <a:defRPr/>
@@ -1114,7 +1162,9 @@
           </a:xfrm>
         </p:spPr>
         <p:txBody>
-          <a:bodyPr anchor="b"/>
+          <a:bodyPr anchor="b">
+            <a:normAutofit xmlns:a="http://schemas.openxmlformats.org/drawingml/2006/main"/>
+          </a:bodyPr>
           <a:lstStyle>
             <a:lvl1pPr marL="0" indent="0">
               <a:buNone/>
@@ -1179,7 +1229,9 @@
           </a:xfrm>
         </p:spPr>
         <p:txBody>
-          <a:bodyPr/>
+          <a:bodyPr>
+            <a:normAutofit xmlns:a="http://schemas.openxmlformats.org/drawingml/2006/main"/>
+          </a:bodyPr>
           <a:lstStyle>
             <a:lvl1pPr>
               <a:defRPr sz="2400"/>
@@ -1264,7 +1316,9 @@
           </a:xfrm>
         </p:spPr>
         <p:txBody>
-          <a:bodyPr anchor="b"/>
+          <a:bodyPr anchor="b">
+            <a:normAutofit xmlns:a="http://schemas.openxmlformats.org/drawingml/2006/main"/>
+          </a:bodyPr>
           <a:lstStyle>
             <a:lvl1pPr marL="0" indent="0">
               <a:buNone/>
@@ -1329,7 +1383,9 @@
           </a:xfrm>
         </p:spPr>
         <p:txBody>
-          <a:bodyPr/>
+          <a:bodyPr>
+            <a:normAutofit xmlns:a="http://schemas.openxmlformats.org/drawingml/2006/main"/>
+          </a:bodyPr>
           <a:lstStyle>
             <a:lvl1pPr>
               <a:defRPr sz="2400"/>
@@ -1409,7 +1465,9 @@
         </p:nvSpPr>
         <p:spPr/>
         <p:txBody>
-          <a:bodyPr/>
+          <a:bodyPr>
+            <a:normAutofit xmlns:a="http://schemas.openxmlformats.org/drawingml/2006/main"/>
+          </a:bodyPr>
           <a:lstStyle/>
           <a:p>
             <a:fld id="{E6744CE3-0875-4B69-89C0-6F72D8139561}" type="datetimeFigureOut">
@@ -1432,7 +1490,9 @@
         </p:nvSpPr>
         <p:spPr/>
         <p:txBody>
-          <a:bodyPr/>
+          <a:bodyPr>
+            <a:normAutofit xmlns:a="http://schemas.openxmlformats.org/drawingml/2006/main"/>
+          </a:bodyPr>
           <a:lstStyle/>
           <a:p>
             <a:endParaRPr lang="en-GB"/>
@@ -1451,7 +1511,9 @@
         </p:nvSpPr>
         <p:spPr/>
         <p:txBody>
-          <a:bodyPr/>
+          <a:bodyPr>
+            <a:normAutofit xmlns:a="http://schemas.openxmlformats.org/drawingml/2006/main"/>
+          </a:bodyPr>
           <a:lstStyle/>
           <a:p>
             <a:fld id="{8DADB20D-508E-4C6D-A9E4-257D5607B0F6}" type="slidenum">
@@ -1504,7 +1566,9 @@
         </p:nvSpPr>
         <p:spPr/>
         <p:txBody>
-          <a:bodyPr/>
+          <a:bodyPr>
+            <a:normAutofit xmlns:a="http://schemas.openxmlformats.org/drawingml/2006/main"/>
+          </a:bodyPr>
           <a:lstStyle/>
           <a:p>
             <a:r>
@@ -1527,7 +1591,9 @@
         </p:nvSpPr>
         <p:spPr/>
         <p:txBody>
-          <a:bodyPr/>
+          <a:bodyPr>
+            <a:normAutofit xmlns:a="http://schemas.openxmlformats.org/drawingml/2006/main"/>
+          </a:bodyPr>
           <a:lstStyle/>
           <a:p>
             <a:fld id="{E6744CE3-0875-4B69-89C0-6F72D8139561}" type="datetimeFigureOut">
@@ -1550,7 +1616,9 @@
         </p:nvSpPr>
         <p:spPr/>
         <p:txBody>
-          <a:bodyPr/>
+          <a:bodyPr>
+            <a:normAutofit xmlns:a="http://schemas.openxmlformats.org/drawingml/2006/main"/>
+          </a:bodyPr>
           <a:lstStyle/>
           <a:p>
             <a:endParaRPr lang="en-GB"/>
@@ -1569,7 +1637,9 @@
         </p:nvSpPr>
         <p:spPr/>
         <p:txBody>
-          <a:bodyPr/>
+          <a:bodyPr>
+            <a:normAutofit xmlns:a="http://schemas.openxmlformats.org/drawingml/2006/main"/>
+          </a:bodyPr>
           <a:lstStyle/>
           <a:p>
             <a:fld id="{8DADB20D-508E-4C6D-A9E4-257D5607B0F6}" type="slidenum">
@@ -1622,7 +1692,9 @@
         </p:nvSpPr>
         <p:spPr/>
         <p:txBody>
-          <a:bodyPr/>
+          <a:bodyPr>
+            <a:normAutofit xmlns:a="http://schemas.openxmlformats.org/drawingml/2006/main"/>
+          </a:bodyPr>
           <a:lstStyle/>
           <a:p>
             <a:fld id="{E6744CE3-0875-4B69-89C0-6F72D8139561}" type="datetimeFigureOut">
@@ -1645,7 +1717,9 @@
         </p:nvSpPr>
         <p:spPr/>
         <p:txBody>
-          <a:bodyPr/>
+          <a:bodyPr>
+            <a:normAutofit xmlns:a="http://schemas.openxmlformats.org/drawingml/2006/main"/>
+          </a:bodyPr>
           <a:lstStyle/>
           <a:p>
             <a:endParaRPr lang="en-GB"/>
@@ -1664,7 +1738,9 @@
         </p:nvSpPr>
         <p:spPr/>
         <p:txBody>
-          <a:bodyPr/>
+          <a:bodyPr>
+            <a:normAutofit xmlns:a="http://schemas.openxmlformats.org/drawingml/2006/main"/>
+          </a:bodyPr>
           <a:lstStyle/>
           <a:p>
             <a:fld id="{8DADB20D-508E-4C6D-A9E4-257D5607B0F6}" type="slidenum">
@@ -1717,7 +1793,9 @@
         </p:nvSpPr>
         <p:spPr/>
         <p:txBody>
-          <a:bodyPr/>
+          <a:bodyPr>
+            <a:normAutofit xmlns:a="http://schemas.openxmlformats.org/drawingml/2006/main"/>
+          </a:bodyPr>
           <a:lstStyle/>
           <a:p>
             <a:r>
@@ -1745,7 +1823,9 @@
           </a:xfrm>
         </p:spPr>
         <p:txBody>
-          <a:bodyPr/>
+          <a:bodyPr>
+            <a:normAutofit xmlns:a="http://schemas.openxmlformats.org/drawingml/2006/main"/>
+          </a:bodyPr>
           <a:lstStyle>
             <a:lvl1pPr>
               <a:defRPr sz="2800"/>
@@ -1830,7 +1910,9 @@
           </a:xfrm>
         </p:spPr>
         <p:txBody>
-          <a:bodyPr/>
+          <a:bodyPr>
+            <a:normAutofit xmlns:a="http://schemas.openxmlformats.org/drawingml/2006/main"/>
+          </a:bodyPr>
           <a:lstStyle>
             <a:lvl1pPr>
               <a:defRPr sz="2800"/>
@@ -1910,7 +1992,9 @@
         </p:nvSpPr>
         <p:spPr/>
         <p:txBody>
-          <a:bodyPr/>
+          <a:bodyPr>
+            <a:normAutofit xmlns:a="http://schemas.openxmlformats.org/drawingml/2006/main"/>
+          </a:bodyPr>
           <a:lstStyle/>
           <a:p>
             <a:fld id="{E6744CE3-0875-4B69-89C0-6F72D8139561}" type="datetimeFigureOut">
@@ -1933,7 +2017,9 @@
         </p:nvSpPr>
         <p:spPr/>
         <p:txBody>
-          <a:bodyPr/>
+          <a:bodyPr>
+            <a:normAutofit xmlns:a="http://schemas.openxmlformats.org/drawingml/2006/main"/>
+          </a:bodyPr>
           <a:lstStyle/>
           <a:p>
             <a:endParaRPr lang="en-GB"/>
@@ -1952,7 +2038,9 @@
         </p:nvSpPr>
         <p:spPr/>
         <p:txBody>
-          <a:bodyPr/>
+          <a:bodyPr>
+            <a:normAutofit xmlns:a="http://schemas.openxmlformats.org/drawingml/2006/main"/>
+          </a:bodyPr>
           <a:lstStyle/>
           <a:p>
             <a:fld id="{8DADB20D-508E-4C6D-A9E4-257D5607B0F6}" type="slidenum">
@@ -2019,7 +2107,7 @@
         </p:spPr>
         <p:txBody>
           <a:bodyPr vert="horz" lIns="91440" tIns="45720" rIns="91440" bIns="45720" rtlCol="0" anchor="ctr">
-            <a:normAutofit/>
+            <a:normAutofit xmlns:a="http://schemas.openxmlformats.org/drawingml/2006/main"/>
           </a:bodyPr>
           <a:lstStyle/>
           <a:p>
@@ -2052,7 +2140,7 @@
         </p:spPr>
         <p:txBody>
           <a:bodyPr vert="horz" lIns="91440" tIns="45720" rIns="91440" bIns="45720" rtlCol="0">
-            <a:normAutofit/>
+            <a:normAutofit xmlns:a="http://schemas.openxmlformats.org/drawingml/2006/main"/>
           </a:bodyPr>
           <a:lstStyle/>
           <a:p>
@@ -2113,7 +2201,9 @@
           </a:prstGeom>
         </p:spPr>
         <p:txBody>
-          <a:bodyPr vert="horz" lIns="91440" tIns="45720" rIns="91440" bIns="45720" rtlCol="0" anchor="ctr"/>
+          <a:bodyPr vert="horz" lIns="91440" tIns="45720" rIns="91440" bIns="45720" rtlCol="0" anchor="ctr">
+            <a:normAutofit xmlns:a="http://schemas.openxmlformats.org/drawingml/2006/main"/>
+          </a:bodyPr>
           <a:lstStyle>
             <a:lvl1pPr algn="l">
               <a:defRPr sz="1200">
@@ -2154,7 +2244,9 @@
           </a:prstGeom>
         </p:spPr>
         <p:txBody>
-          <a:bodyPr vert="horz" lIns="91440" tIns="45720" rIns="91440" bIns="45720" rtlCol="0" anchor="ctr"/>
+          <a:bodyPr vert="horz" lIns="91440" tIns="45720" rIns="91440" bIns="45720" rtlCol="0" anchor="ctr">
+            <a:normAutofit xmlns:a="http://schemas.openxmlformats.org/drawingml/2006/main"/>
+          </a:bodyPr>
           <a:lstStyle>
             <a:lvl1pPr algn="ctr">
               <a:defRPr sz="1200">
@@ -2191,7 +2283,9 @@
           </a:prstGeom>
         </p:spPr>
         <p:txBody>
-          <a:bodyPr vert="horz" lIns="91440" tIns="45720" rIns="91440" bIns="45720" rtlCol="0" anchor="ctr"/>
+          <a:bodyPr vert="horz" lIns="91440" tIns="45720" rIns="91440" bIns="45720" rtlCol="0" anchor="ctr">
+            <a:normAutofit xmlns:a="http://schemas.openxmlformats.org/drawingml/2006/main"/>
+          </a:bodyPr>
           <a:lstStyle>
             <a:lvl1pPr algn="r">
               <a:defRPr sz="1200">
@@ -2232,14 +2326,14 @@
   </p:sldLayoutIdLst>
   <p:txStyles>
     <p:titleStyle>
-      <a:lvl1pPr algn="ctr" defTabSz="914400" rtl="0" eaLnBrk="1" latinLnBrk="0" hangingPunct="1">
+      <a:lvl1pPr algn="l" defTabSz="914400" rtl="0" eaLnBrk="1" latinLnBrk="0" hangingPunct="1">
         <a:spcBef>
           <a:spcPct val="0"/>
         </a:spcBef>
         <a:buNone/>
-        <a:defRPr sz="4400" kern="1200">
-          <a:solidFill>
-            <a:schemeClr val="tx1"/>
+        <a:defRPr sz="2400" kern="1200">
+          <a:solidFill xmlns:a="http://schemas.openxmlformats.org/drawingml/2006/main">
+            <a:srgbClr val="12314E"/>
           </a:solidFill>
           <a:latin typeface="+mj-lt"/>
           <a:ea typeface="+mj-ea"/>
@@ -2254,7 +2348,7 @@
         </a:spcBef>
         <a:buFont typeface="Arial" panose="020B0604020202020204" pitchFamily="34" charset="0"/>
         <a:buChar char="•"/>
-        <a:defRPr sz="3200" kern="1200">
+        <a:defRPr sz="1400" kern="1200">
           <a:solidFill>
             <a:schemeClr val="tx1"/>
           </a:solidFill>
@@ -2500,28 +2594,28 @@
         <a:sysClr val="window" lastClr="FFFFFF"/>
       </a:lt1>
       <a:dk2>
-        <a:srgbClr val="1F497D"/>
+        <a:srgbClr val="12314E"/>
       </a:dk2>
       <a:lt2>
-        <a:srgbClr val="EEECE1"/>
+        <a:srgbClr val="EEF1F5"/>
       </a:lt2>
       <a:accent1>
-        <a:srgbClr val="4F81BD"/>
+        <a:srgbClr val="12314E"/>
       </a:accent1>
       <a:accent2>
-        <a:srgbClr val="C0504D"/>
+        <a:srgbClr val="C9A227"/>
       </a:accent2>
       <a:accent3>
-        <a:srgbClr val="9BBB59"/>
+        <a:srgbClr val="3E6E8E"/>
       </a:accent3>
       <a:accent4>
-        <a:srgbClr val="8064A2"/>
+        <a:srgbClr val="6E7C8C"/>
       </a:accent4>
       <a:accent5>
-        <a:srgbClr val="4BACC6"/>
+        <a:srgbClr val="A9B4C0"/>
       </a:accent5>
       <a:accent6>
-        <a:srgbClr val="F79646"/>
+        <a:srgbClr val="D8B04A"/>
       </a:accent6>
       <a:hlink>
         <a:srgbClr val="0000FF"/>

</xml_diff>

<commit_message>
Fix error messages region coverage Add package logo pages workflow
</commit_message>
<xml_diff>
--- a/ezr-survey/inst/templates/ezrsurvey-16x9-plain.pptx
+++ b/ezr-survey/inst/templates/ezrsurvey-16x9-plain.pptx
@@ -4,11 +4,9 @@
   <p:sldMasterIdLst>
     <p:sldMasterId id="2147483648" r:id="rId1"/>
   </p:sldMasterIdLst>
+  <p:sldIdLst/>
   <p:sldSz cx="12192000" cy="6858000"/>
   <p:notesSz cx="6858000" cy="9144000"/>
-  <p:custDataLst>
-    <p:tags r:id="rId3"/>
-  </p:custDataLst>
   <p:defaultTextStyle>
     <a:defPPr>
       <a:defRPr lang="en-US"/>
@@ -104,6 +102,11 @@
       </a:defRPr>
     </a:lvl9pPr>
   </p:defaultTextStyle>
+  <p:extLst>
+    <p:ext uri="{EFAFB233-063F-42B5-8137-9DF3F51BA10A}">
+      <p15:sldGuideLst xmlns:p15="http://schemas.microsoft.com/office/powerpoint/2012/main"/>
+    </p:ext>
+  </p:extLst>
 </p:presentation>
 </file>
 
@@ -126,7 +129,13 @@
       </p:grpSpPr>
       <p:sp>
         <p:nvSpPr>
-          <p:cNvPr id="2" name="Title 1"/>
+          <p:cNvPr id="2" name="Title 1">
+            <a:extLst>
+              <a:ext uri="{FF2B5EF4-FFF2-40B4-BE49-F238E27FC236}">
+                <a16:creationId xmlns:a16="http://schemas.microsoft.com/office/drawing/2014/main" id="{D33906BE-1878-492D-BF60-5BA94754CDED}"/>
+              </a:ext>
+            </a:extLst>
+          </p:cNvPr>
           <p:cNvSpPr>
             <a:spLocks noGrp="1"/>
           </p:cNvSpPr>
@@ -136,31 +145,37 @@
         </p:nvSpPr>
         <p:spPr>
           <a:xfrm>
-            <a:off x="914400" y="2130425"/>
-            <a:ext cx="10363200" cy="1470025"/>
+            <a:off x="1524000" y="1122363"/>
+            <a:ext cx="9144000" cy="2387600"/>
           </a:xfrm>
         </p:spPr>
         <p:txBody>
-          <a:bodyPr>
+          <a:bodyPr anchor="b">
             <a:normAutofit xmlns:a="http://schemas.openxmlformats.org/drawingml/2006/main"/>
           </a:bodyPr>
           <a:lstStyle>
-            <a:lvl1pPr xmlns:a="http://schemas.openxmlformats.org/drawingml/2006/main" algn="l">
-              <a:defRPr xmlns:a="http://schemas.openxmlformats.org/drawingml/2006/main" sz="4000" b="1"/>
+            <a:lvl1pPr algn="l">
+              <a:defRPr sz="4000" b="1"/>
             </a:lvl1pPr>
           </a:lstStyle>
           <a:p>
             <a:r>
-              <a:rPr lang="en-US" smtClean="0"/>
+              <a:rPr lang="en-US"/>
               <a:t>Click to edit Master title style</a:t>
             </a:r>
-            <a:endParaRPr lang="en-GB"/>
-          </a:p>
-        </p:txBody>
-      </p:sp>
-      <p:sp>
-        <p:nvSpPr>
-          <p:cNvPr id="3" name="Subtitle 2"/>
+            <a:endParaRPr lang="en-GB" dirty="0"/>
+          </a:p>
+        </p:txBody>
+      </p:sp>
+      <p:sp>
+        <p:nvSpPr>
+          <p:cNvPr id="3" name="Subtitle 2">
+            <a:extLst>
+              <a:ext uri="{FF2B5EF4-FFF2-40B4-BE49-F238E27FC236}">
+                <a16:creationId xmlns:a16="http://schemas.microsoft.com/office/drawing/2014/main" id="{82505D6C-47D0-4ABB-BD96-BDE16BC1B848}"/>
+              </a:ext>
+            </a:extLst>
+          </p:cNvPr>
           <p:cNvSpPr>
             <a:spLocks noGrp="1"/>
           </p:cNvSpPr>
@@ -170,8 +185,8 @@
         </p:nvSpPr>
         <p:spPr>
           <a:xfrm>
-            <a:off x="1828800" y="3886200"/>
-            <a:ext cx="8534400" cy="1752600"/>
+            <a:off x="1524000" y="3602038"/>
+            <a:ext cx="9144000" cy="1655762"/>
           </a:xfrm>
         </p:spPr>
         <p:txBody>
@@ -181,98 +196,44 @@
           <a:lstStyle>
             <a:lvl1pPr marL="0" indent="0" algn="l">
               <a:buNone/>
-              <a:defRPr sz="1800">
-                <a:solidFill>
-                  <a:schemeClr val="tx1">
-                    <a:tint val="75000"/>
-                  </a:schemeClr>
-                </a:solidFill>
-              </a:defRPr>
+              <a:defRPr sz="1800"/>
             </a:lvl1pPr>
             <a:lvl2pPr marL="457200" indent="0" algn="ctr">
               <a:buNone/>
-              <a:defRPr>
-                <a:solidFill>
-                  <a:schemeClr val="tx1">
-                    <a:tint val="75000"/>
-                  </a:schemeClr>
-                </a:solidFill>
-              </a:defRPr>
+              <a:defRPr sz="2000"/>
             </a:lvl2pPr>
             <a:lvl3pPr marL="914400" indent="0" algn="ctr">
               <a:buNone/>
-              <a:defRPr>
-                <a:solidFill>
-                  <a:schemeClr val="tx1">
-                    <a:tint val="75000"/>
-                  </a:schemeClr>
-                </a:solidFill>
-              </a:defRPr>
+              <a:defRPr sz="1800"/>
             </a:lvl3pPr>
             <a:lvl4pPr marL="1371600" indent="0" algn="ctr">
               <a:buNone/>
-              <a:defRPr>
-                <a:solidFill>
-                  <a:schemeClr val="tx1">
-                    <a:tint val="75000"/>
-                  </a:schemeClr>
-                </a:solidFill>
-              </a:defRPr>
+              <a:defRPr sz="1600"/>
             </a:lvl4pPr>
             <a:lvl5pPr marL="1828800" indent="0" algn="ctr">
               <a:buNone/>
-              <a:defRPr>
-                <a:solidFill>
-                  <a:schemeClr val="tx1">
-                    <a:tint val="75000"/>
-                  </a:schemeClr>
-                </a:solidFill>
-              </a:defRPr>
+              <a:defRPr sz="1600"/>
             </a:lvl5pPr>
             <a:lvl6pPr marL="2286000" indent="0" algn="ctr">
               <a:buNone/>
-              <a:defRPr>
-                <a:solidFill>
-                  <a:schemeClr val="tx1">
-                    <a:tint val="75000"/>
-                  </a:schemeClr>
-                </a:solidFill>
-              </a:defRPr>
+              <a:defRPr sz="1600"/>
             </a:lvl6pPr>
             <a:lvl7pPr marL="2743200" indent="0" algn="ctr">
               <a:buNone/>
-              <a:defRPr>
-                <a:solidFill>
-                  <a:schemeClr val="tx1">
-                    <a:tint val="75000"/>
-                  </a:schemeClr>
-                </a:solidFill>
-              </a:defRPr>
+              <a:defRPr sz="1600"/>
             </a:lvl7pPr>
             <a:lvl8pPr marL="3200400" indent="0" algn="ctr">
               <a:buNone/>
-              <a:defRPr>
-                <a:solidFill>
-                  <a:schemeClr val="tx1">
-                    <a:tint val="75000"/>
-                  </a:schemeClr>
-                </a:solidFill>
-              </a:defRPr>
+              <a:defRPr sz="1600"/>
             </a:lvl8pPr>
             <a:lvl9pPr marL="3657600" indent="0" algn="ctr">
               <a:buNone/>
-              <a:defRPr>
-                <a:solidFill>
-                  <a:schemeClr val="tx1">
-                    <a:tint val="75000"/>
-                  </a:schemeClr>
-                </a:solidFill>
-              </a:defRPr>
+              <a:defRPr sz="1600"/>
             </a:lvl9pPr>
           </a:lstStyle>
           <a:p>
             <a:r>
-              <a:rPr lang="en-US" smtClean="0"/>
+              <a:rPr lang="en-US"/>
               <a:t>Click to edit Master subtitle style</a:t>
             </a:r>
             <a:endParaRPr lang="en-GB"/>
@@ -281,7 +242,13 @@
       </p:sp>
       <p:sp>
         <p:nvSpPr>
-          <p:cNvPr id="4" name="Date Placeholder 3"/>
+          <p:cNvPr id="4" name="Date Placeholder 3">
+            <a:extLst>
+              <a:ext uri="{FF2B5EF4-FFF2-40B4-BE49-F238E27FC236}">
+                <a16:creationId xmlns:a16="http://schemas.microsoft.com/office/drawing/2014/main" id="{3EC77FED-AE91-409E-B47D-0E184EBEC046}"/>
+              </a:ext>
+            </a:extLst>
+          </p:cNvPr>
           <p:cNvSpPr>
             <a:spLocks noGrp="1"/>
           </p:cNvSpPr>
@@ -296,17 +263,23 @@
           </a:bodyPr>
           <a:lstStyle/>
           <a:p>
-            <a:fld id="{E6744CE3-0875-4B69-89C0-6F72D8139561}" type="datetimeFigureOut">
+            <a:fld id="{EA9C4514-AD86-4E80-B6BC-BD70E0C475B2}" type="datetimeFigureOut">
               <a:rPr lang="en-GB" smtClean="0"/>
-              <a:t>26/05/17</a:t>
+              <a:t>29/09/2026</a:t>
             </a:fld>
-            <a:endParaRPr lang="en-GB"/>
-          </a:p>
-        </p:txBody>
-      </p:sp>
-      <p:sp>
-        <p:nvSpPr>
-          <p:cNvPr id="5" name="Footer Placeholder 4"/>
+            <a:endParaRPr lang="en-GB" dirty="0"/>
+          </a:p>
+        </p:txBody>
+      </p:sp>
+      <p:sp>
+        <p:nvSpPr>
+          <p:cNvPr id="5" name="Footer Placeholder 4">
+            <a:extLst>
+              <a:ext uri="{FF2B5EF4-FFF2-40B4-BE49-F238E27FC236}">
+                <a16:creationId xmlns:a16="http://schemas.microsoft.com/office/drawing/2014/main" id="{BEBBE8F0-0D01-4F17-915B-D30087E4D709}"/>
+              </a:ext>
+            </a:extLst>
+          </p:cNvPr>
           <p:cNvSpPr>
             <a:spLocks noGrp="1"/>
           </p:cNvSpPr>
@@ -327,7 +300,13 @@
       </p:sp>
       <p:sp>
         <p:nvSpPr>
-          <p:cNvPr id="6" name="Slide Number Placeholder 5"/>
+          <p:cNvPr id="6" name="Slide Number Placeholder 5">
+            <a:extLst>
+              <a:ext uri="{FF2B5EF4-FFF2-40B4-BE49-F238E27FC236}">
+                <a16:creationId xmlns:a16="http://schemas.microsoft.com/office/drawing/2014/main" id="{B7768C4D-5DAB-42EC-80EA-4A12E9B58C95}"/>
+              </a:ext>
+            </a:extLst>
+          </p:cNvPr>
           <p:cNvSpPr>
             <a:spLocks noGrp="1"/>
           </p:cNvSpPr>
@@ -342,7 +321,7 @@
           </a:bodyPr>
           <a:lstStyle/>
           <a:p>
-            <a:fld id="{8DADB20D-508E-4C6D-A9E4-257D5607B0F6}" type="slidenum">
+            <a:fld id="{E3EE339C-4041-4A50-8D8F-1CA5E34F9F57}" type="slidenum">
               <a:rPr lang="en-GB" smtClean="0"/>
               <a:t>‹#›</a:t>
             </a:fld>
@@ -353,7 +332,437 @@
     </p:spTree>
     <p:extLst>
       <p:ext uri="{BB962C8B-B14F-4D97-AF65-F5344CB8AC3E}">
-        <p14:creationId xmlns:p14="http://schemas.microsoft.com/office/powerpoint/2010/main" val="4214881138"/>
+        <p14:creationId xmlns:p14="http://schemas.microsoft.com/office/powerpoint/2010/main" val="1543906133"/>
+      </p:ext>
+    </p:extLst>
+  </p:cSld>
+  <p:clrMapOvr>
+    <a:masterClrMapping/>
+  </p:clrMapOvr>
+</p:sldLayout>
+</file>
+
+<file path=ppt/slideLayouts/slideLayout10.xml><?xml version="1.0" encoding="utf-8"?>
+<p:sldLayout xmlns:a="http://schemas.openxmlformats.org/drawingml/2006/main" xmlns:r="http://schemas.openxmlformats.org/officeDocument/2006/relationships" xmlns:p="http://schemas.openxmlformats.org/presentationml/2006/main" type="vertTx" preserve="1">
+  <p:cSld name="Title and Vertical Text">
+    <p:spTree>
+      <p:nvGrpSpPr>
+        <p:cNvPr id="1" name=""/>
+        <p:cNvGrpSpPr/>
+        <p:nvPr/>
+      </p:nvGrpSpPr>
+      <p:grpSpPr>
+        <a:xfrm>
+          <a:off x="0" y="0"/>
+          <a:ext cx="0" cy="0"/>
+          <a:chOff x="0" y="0"/>
+          <a:chExt cx="0" cy="0"/>
+        </a:xfrm>
+      </p:grpSpPr>
+      <p:sp>
+        <p:nvSpPr>
+          <p:cNvPr id="2" name="Title 1">
+            <a:extLst>
+              <a:ext uri="{FF2B5EF4-FFF2-40B4-BE49-F238E27FC236}">
+                <a16:creationId xmlns:a16="http://schemas.microsoft.com/office/drawing/2014/main" id="{628A6456-8F2C-4402-948F-809021C7D7E3}"/>
+              </a:ext>
+            </a:extLst>
+          </p:cNvPr>
+          <p:cNvSpPr>
+            <a:spLocks noGrp="1"/>
+          </p:cNvSpPr>
+          <p:nvPr>
+            <p:ph type="title"/>
+          </p:nvPr>
+        </p:nvSpPr>
+        <p:spPr/>
+        <p:txBody>
+          <a:bodyPr>
+            <a:normAutofit xmlns:a="http://schemas.openxmlformats.org/drawingml/2006/main"/>
+          </a:bodyPr>
+          <a:lstStyle/>
+          <a:p>
+            <a:r>
+              <a:rPr lang="en-US"/>
+              <a:t>Click to edit Master title style</a:t>
+            </a:r>
+            <a:endParaRPr lang="en-GB"/>
+          </a:p>
+        </p:txBody>
+      </p:sp>
+      <p:sp>
+        <p:nvSpPr>
+          <p:cNvPr id="3" name="Vertical Text Placeholder 2">
+            <a:extLst>
+              <a:ext uri="{FF2B5EF4-FFF2-40B4-BE49-F238E27FC236}">
+                <a16:creationId xmlns:a16="http://schemas.microsoft.com/office/drawing/2014/main" id="{BB132DCE-21D6-4D0F-BAF3-F767FE7F549A}"/>
+              </a:ext>
+            </a:extLst>
+          </p:cNvPr>
+          <p:cNvSpPr>
+            <a:spLocks noGrp="1"/>
+          </p:cNvSpPr>
+          <p:nvPr>
+            <p:ph type="body" orient="vert" idx="1"/>
+          </p:nvPr>
+        </p:nvSpPr>
+        <p:spPr/>
+        <p:txBody>
+          <a:bodyPr vert="eaVert">
+            <a:normAutofit xmlns:a="http://schemas.openxmlformats.org/drawingml/2006/main"/>
+          </a:bodyPr>
+          <a:lstStyle/>
+          <a:p>
+            <a:pPr lvl="0"/>
+            <a:r>
+              <a:rPr lang="en-US"/>
+              <a:t>Click to edit Master text styles</a:t>
+            </a:r>
+          </a:p>
+          <a:p>
+            <a:pPr lvl="1"/>
+            <a:r>
+              <a:rPr lang="en-US"/>
+              <a:t>Second level</a:t>
+            </a:r>
+          </a:p>
+          <a:p>
+            <a:pPr lvl="2"/>
+            <a:r>
+              <a:rPr lang="en-US"/>
+              <a:t>Third level</a:t>
+            </a:r>
+          </a:p>
+          <a:p>
+            <a:pPr lvl="3"/>
+            <a:r>
+              <a:rPr lang="en-US"/>
+              <a:t>Fourth level</a:t>
+            </a:r>
+          </a:p>
+          <a:p>
+            <a:pPr lvl="4"/>
+            <a:r>
+              <a:rPr lang="en-US"/>
+              <a:t>Fifth level</a:t>
+            </a:r>
+            <a:endParaRPr lang="en-GB"/>
+          </a:p>
+        </p:txBody>
+      </p:sp>
+      <p:sp>
+        <p:nvSpPr>
+          <p:cNvPr id="4" name="Date Placeholder 3">
+            <a:extLst>
+              <a:ext uri="{FF2B5EF4-FFF2-40B4-BE49-F238E27FC236}">
+                <a16:creationId xmlns:a16="http://schemas.microsoft.com/office/drawing/2014/main" id="{F33B38AB-C501-49D2-A1C2-2D4892166214}"/>
+              </a:ext>
+            </a:extLst>
+          </p:cNvPr>
+          <p:cNvSpPr>
+            <a:spLocks noGrp="1"/>
+          </p:cNvSpPr>
+          <p:nvPr>
+            <p:ph type="dt" sz="half" idx="10"/>
+          </p:nvPr>
+        </p:nvSpPr>
+        <p:spPr/>
+        <p:txBody>
+          <a:bodyPr>
+            <a:normAutofit xmlns:a="http://schemas.openxmlformats.org/drawingml/2006/main"/>
+          </a:bodyPr>
+          <a:lstStyle/>
+          <a:p>
+            <a:fld id="{EA9C4514-AD86-4E80-B6BC-BD70E0C475B2}" type="datetimeFigureOut">
+              <a:rPr lang="en-GB" smtClean="0"/>
+              <a:t>29/09/2026</a:t>
+            </a:fld>
+            <a:endParaRPr lang="en-GB"/>
+          </a:p>
+        </p:txBody>
+      </p:sp>
+      <p:sp>
+        <p:nvSpPr>
+          <p:cNvPr id="5" name="Footer Placeholder 4">
+            <a:extLst>
+              <a:ext uri="{FF2B5EF4-FFF2-40B4-BE49-F238E27FC236}">
+                <a16:creationId xmlns:a16="http://schemas.microsoft.com/office/drawing/2014/main" id="{FBE42019-C1C8-40ED-BEFB-C373ACD9C9F9}"/>
+              </a:ext>
+            </a:extLst>
+          </p:cNvPr>
+          <p:cNvSpPr>
+            <a:spLocks noGrp="1"/>
+          </p:cNvSpPr>
+          <p:nvPr>
+            <p:ph type="ftr" sz="quarter" idx="11"/>
+          </p:nvPr>
+        </p:nvSpPr>
+        <p:spPr/>
+        <p:txBody>
+          <a:bodyPr>
+            <a:normAutofit xmlns:a="http://schemas.openxmlformats.org/drawingml/2006/main"/>
+          </a:bodyPr>
+          <a:lstStyle/>
+          <a:p>
+            <a:endParaRPr lang="en-GB"/>
+          </a:p>
+        </p:txBody>
+      </p:sp>
+      <p:sp>
+        <p:nvSpPr>
+          <p:cNvPr id="6" name="Slide Number Placeholder 5">
+            <a:extLst>
+              <a:ext uri="{FF2B5EF4-FFF2-40B4-BE49-F238E27FC236}">
+                <a16:creationId xmlns:a16="http://schemas.microsoft.com/office/drawing/2014/main" id="{CFCB72E6-92C7-4301-8382-F7FAE8C73C97}"/>
+              </a:ext>
+            </a:extLst>
+          </p:cNvPr>
+          <p:cNvSpPr>
+            <a:spLocks noGrp="1"/>
+          </p:cNvSpPr>
+          <p:nvPr>
+            <p:ph type="sldNum" sz="quarter" idx="12"/>
+          </p:nvPr>
+        </p:nvSpPr>
+        <p:spPr/>
+        <p:txBody>
+          <a:bodyPr>
+            <a:normAutofit xmlns:a="http://schemas.openxmlformats.org/drawingml/2006/main"/>
+          </a:bodyPr>
+          <a:lstStyle/>
+          <a:p>
+            <a:fld id="{E3EE339C-4041-4A50-8D8F-1CA5E34F9F57}" type="slidenum">
+              <a:rPr lang="en-GB" smtClean="0"/>
+              <a:t>‹#›</a:t>
+            </a:fld>
+            <a:endParaRPr lang="en-GB"/>
+          </a:p>
+        </p:txBody>
+      </p:sp>
+    </p:spTree>
+    <p:extLst>
+      <p:ext uri="{BB962C8B-B14F-4D97-AF65-F5344CB8AC3E}">
+        <p14:creationId xmlns:p14="http://schemas.microsoft.com/office/powerpoint/2010/main" val="2208136378"/>
+      </p:ext>
+    </p:extLst>
+  </p:cSld>
+  <p:clrMapOvr>
+    <a:masterClrMapping/>
+  </p:clrMapOvr>
+</p:sldLayout>
+</file>
+
+<file path=ppt/slideLayouts/slideLayout11.xml><?xml version="1.0" encoding="utf-8"?>
+<p:sldLayout xmlns:a="http://schemas.openxmlformats.org/drawingml/2006/main" xmlns:r="http://schemas.openxmlformats.org/officeDocument/2006/relationships" xmlns:p="http://schemas.openxmlformats.org/presentationml/2006/main" type="vertTitleAndTx" preserve="1">
+  <p:cSld name="Vertical Title and Text">
+    <p:spTree>
+      <p:nvGrpSpPr>
+        <p:cNvPr id="1" name=""/>
+        <p:cNvGrpSpPr/>
+        <p:nvPr/>
+      </p:nvGrpSpPr>
+      <p:grpSpPr>
+        <a:xfrm>
+          <a:off x="0" y="0"/>
+          <a:ext cx="0" cy="0"/>
+          <a:chOff x="0" y="0"/>
+          <a:chExt cx="0" cy="0"/>
+        </a:xfrm>
+      </p:grpSpPr>
+      <p:sp>
+        <p:nvSpPr>
+          <p:cNvPr id="2" name="Vertical Title 1">
+            <a:extLst>
+              <a:ext uri="{FF2B5EF4-FFF2-40B4-BE49-F238E27FC236}">
+                <a16:creationId xmlns:a16="http://schemas.microsoft.com/office/drawing/2014/main" id="{78D22F5D-362C-4DA5-A5C1-8201C2766A09}"/>
+              </a:ext>
+            </a:extLst>
+          </p:cNvPr>
+          <p:cNvSpPr>
+            <a:spLocks noGrp="1"/>
+          </p:cNvSpPr>
+          <p:nvPr>
+            <p:ph type="title" orient="vert"/>
+          </p:nvPr>
+        </p:nvSpPr>
+        <p:spPr>
+          <a:xfrm>
+            <a:off x="8724900" y="365125"/>
+            <a:ext cx="2628900" cy="5811838"/>
+          </a:xfrm>
+        </p:spPr>
+        <p:txBody>
+          <a:bodyPr vert="eaVert">
+            <a:normAutofit xmlns:a="http://schemas.openxmlformats.org/drawingml/2006/main"/>
+          </a:bodyPr>
+          <a:lstStyle/>
+          <a:p>
+            <a:r>
+              <a:rPr lang="en-US"/>
+              <a:t>Click to edit Master title style</a:t>
+            </a:r>
+            <a:endParaRPr lang="en-GB"/>
+          </a:p>
+        </p:txBody>
+      </p:sp>
+      <p:sp>
+        <p:nvSpPr>
+          <p:cNvPr id="3" name="Vertical Text Placeholder 2">
+            <a:extLst>
+              <a:ext uri="{FF2B5EF4-FFF2-40B4-BE49-F238E27FC236}">
+                <a16:creationId xmlns:a16="http://schemas.microsoft.com/office/drawing/2014/main" id="{499FC995-C26F-4226-BEC3-3D8D3B082BB0}"/>
+              </a:ext>
+            </a:extLst>
+          </p:cNvPr>
+          <p:cNvSpPr>
+            <a:spLocks noGrp="1"/>
+          </p:cNvSpPr>
+          <p:nvPr>
+            <p:ph type="body" orient="vert" idx="1"/>
+          </p:nvPr>
+        </p:nvSpPr>
+        <p:spPr>
+          <a:xfrm>
+            <a:off x="838200" y="365125"/>
+            <a:ext cx="7734300" cy="5811838"/>
+          </a:xfrm>
+        </p:spPr>
+        <p:txBody>
+          <a:bodyPr vert="eaVert">
+            <a:normAutofit xmlns:a="http://schemas.openxmlformats.org/drawingml/2006/main"/>
+          </a:bodyPr>
+          <a:lstStyle/>
+          <a:p>
+            <a:pPr lvl="0"/>
+            <a:r>
+              <a:rPr lang="en-US"/>
+              <a:t>Click to edit Master text styles</a:t>
+            </a:r>
+          </a:p>
+          <a:p>
+            <a:pPr lvl="1"/>
+            <a:r>
+              <a:rPr lang="en-US"/>
+              <a:t>Second level</a:t>
+            </a:r>
+          </a:p>
+          <a:p>
+            <a:pPr lvl="2"/>
+            <a:r>
+              <a:rPr lang="en-US"/>
+              <a:t>Third level</a:t>
+            </a:r>
+          </a:p>
+          <a:p>
+            <a:pPr lvl="3"/>
+            <a:r>
+              <a:rPr lang="en-US"/>
+              <a:t>Fourth level</a:t>
+            </a:r>
+          </a:p>
+          <a:p>
+            <a:pPr lvl="4"/>
+            <a:r>
+              <a:rPr lang="en-US"/>
+              <a:t>Fifth level</a:t>
+            </a:r>
+            <a:endParaRPr lang="en-GB"/>
+          </a:p>
+        </p:txBody>
+      </p:sp>
+      <p:sp>
+        <p:nvSpPr>
+          <p:cNvPr id="4" name="Date Placeholder 3">
+            <a:extLst>
+              <a:ext uri="{FF2B5EF4-FFF2-40B4-BE49-F238E27FC236}">
+                <a16:creationId xmlns:a16="http://schemas.microsoft.com/office/drawing/2014/main" id="{A897E21A-71CA-4B1C-A0DD-1B825564C959}"/>
+              </a:ext>
+            </a:extLst>
+          </p:cNvPr>
+          <p:cNvSpPr>
+            <a:spLocks noGrp="1"/>
+          </p:cNvSpPr>
+          <p:nvPr>
+            <p:ph type="dt" sz="half" idx="10"/>
+          </p:nvPr>
+        </p:nvSpPr>
+        <p:spPr/>
+        <p:txBody>
+          <a:bodyPr>
+            <a:normAutofit xmlns:a="http://schemas.openxmlformats.org/drawingml/2006/main"/>
+          </a:bodyPr>
+          <a:lstStyle/>
+          <a:p>
+            <a:fld id="{EA9C4514-AD86-4E80-B6BC-BD70E0C475B2}" type="datetimeFigureOut">
+              <a:rPr lang="en-GB" smtClean="0"/>
+              <a:t>29/09/2026</a:t>
+            </a:fld>
+            <a:endParaRPr lang="en-GB"/>
+          </a:p>
+        </p:txBody>
+      </p:sp>
+      <p:sp>
+        <p:nvSpPr>
+          <p:cNvPr id="5" name="Footer Placeholder 4">
+            <a:extLst>
+              <a:ext uri="{FF2B5EF4-FFF2-40B4-BE49-F238E27FC236}">
+                <a16:creationId xmlns:a16="http://schemas.microsoft.com/office/drawing/2014/main" id="{D0BE01DD-D312-42F7-84B2-E24019EDD8CD}"/>
+              </a:ext>
+            </a:extLst>
+          </p:cNvPr>
+          <p:cNvSpPr>
+            <a:spLocks noGrp="1"/>
+          </p:cNvSpPr>
+          <p:nvPr>
+            <p:ph type="ftr" sz="quarter" idx="11"/>
+          </p:nvPr>
+        </p:nvSpPr>
+        <p:spPr/>
+        <p:txBody>
+          <a:bodyPr>
+            <a:normAutofit xmlns:a="http://schemas.openxmlformats.org/drawingml/2006/main"/>
+          </a:bodyPr>
+          <a:lstStyle/>
+          <a:p>
+            <a:endParaRPr lang="en-GB"/>
+          </a:p>
+        </p:txBody>
+      </p:sp>
+      <p:sp>
+        <p:nvSpPr>
+          <p:cNvPr id="6" name="Slide Number Placeholder 5">
+            <a:extLst>
+              <a:ext uri="{FF2B5EF4-FFF2-40B4-BE49-F238E27FC236}">
+                <a16:creationId xmlns:a16="http://schemas.microsoft.com/office/drawing/2014/main" id="{B08BFB9F-F4BE-49E9-BA89-9C52CED85DB1}"/>
+              </a:ext>
+            </a:extLst>
+          </p:cNvPr>
+          <p:cNvSpPr>
+            <a:spLocks noGrp="1"/>
+          </p:cNvSpPr>
+          <p:nvPr>
+            <p:ph type="sldNum" sz="quarter" idx="12"/>
+          </p:nvPr>
+        </p:nvSpPr>
+        <p:spPr/>
+        <p:txBody>
+          <a:bodyPr>
+            <a:normAutofit xmlns:a="http://schemas.openxmlformats.org/drawingml/2006/main"/>
+          </a:bodyPr>
+          <a:lstStyle/>
+          <a:p>
+            <a:fld id="{E3EE339C-4041-4A50-8D8F-1CA5E34F9F57}" type="slidenum">
+              <a:rPr lang="en-GB" smtClean="0"/>
+              <a:t>‹#›</a:t>
+            </a:fld>
+            <a:endParaRPr lang="en-GB"/>
+          </a:p>
+        </p:txBody>
+      </p:sp>
+    </p:spTree>
+    <p:extLst>
+      <p:ext uri="{BB962C8B-B14F-4D97-AF65-F5344CB8AC3E}">
+        <p14:creationId xmlns:p14="http://schemas.microsoft.com/office/powerpoint/2010/main" val="270522465"/>
       </p:ext>
     </p:extLst>
   </p:cSld>
@@ -382,7 +791,13 @@
       </p:grpSpPr>
       <p:sp>
         <p:nvSpPr>
-          <p:cNvPr id="2" name="Title 1"/>
+          <p:cNvPr id="2" name="Title 1">
+            <a:extLst>
+              <a:ext uri="{FF2B5EF4-FFF2-40B4-BE49-F238E27FC236}">
+                <a16:creationId xmlns:a16="http://schemas.microsoft.com/office/drawing/2014/main" id="{1CBB8EA5-5314-4917-99D1-D3A664D4BE18}"/>
+              </a:ext>
+            </a:extLst>
+          </p:cNvPr>
           <p:cNvSpPr>
             <a:spLocks noGrp="1"/>
           </p:cNvSpPr>
@@ -398,7 +813,7 @@
           <a:lstStyle/>
           <a:p>
             <a:r>
-              <a:rPr lang="en-US" smtClean="0"/>
+              <a:rPr lang="en-US"/>
               <a:t>Click to edit Master title style</a:t>
             </a:r>
             <a:endParaRPr lang="en-GB"/>
@@ -407,7 +822,13 @@
       </p:sp>
       <p:sp>
         <p:nvSpPr>
-          <p:cNvPr id="3" name="Content Placeholder 2"/>
+          <p:cNvPr id="3" name="Content Placeholder 2">
+            <a:extLst>
+              <a:ext uri="{FF2B5EF4-FFF2-40B4-BE49-F238E27FC236}">
+                <a16:creationId xmlns:a16="http://schemas.microsoft.com/office/drawing/2014/main" id="{2CD03A6A-436B-436B-A0F3-43C40B392618}"/>
+              </a:ext>
+            </a:extLst>
+          </p:cNvPr>
           <p:cNvSpPr>
             <a:spLocks noGrp="1"/>
           </p:cNvSpPr>
@@ -424,35 +845,35 @@
           <a:p>
             <a:pPr lvl="0"/>
             <a:r>
-              <a:rPr lang="en-US" smtClean="0"/>
+              <a:rPr lang="en-US"/>
               <a:t>Click to edit Master text styles</a:t>
             </a:r>
           </a:p>
           <a:p>
             <a:pPr lvl="1"/>
             <a:r>
-              <a:rPr lang="en-US" smtClean="0"/>
+              <a:rPr lang="en-US"/>
               <a:t>Second level</a:t>
             </a:r>
           </a:p>
           <a:p>
             <a:pPr lvl="2"/>
             <a:r>
-              <a:rPr lang="en-US" smtClean="0"/>
+              <a:rPr lang="en-US"/>
               <a:t>Third level</a:t>
             </a:r>
           </a:p>
           <a:p>
             <a:pPr lvl="3"/>
             <a:r>
-              <a:rPr lang="en-US" smtClean="0"/>
+              <a:rPr lang="en-US"/>
               <a:t>Fourth level</a:t>
             </a:r>
           </a:p>
           <a:p>
             <a:pPr lvl="4"/>
             <a:r>
-              <a:rPr lang="en-US" smtClean="0"/>
+              <a:rPr lang="en-US"/>
               <a:t>Fifth level</a:t>
             </a:r>
             <a:endParaRPr lang="en-GB"/>
@@ -461,7 +882,13 @@
       </p:sp>
       <p:sp>
         <p:nvSpPr>
-          <p:cNvPr id="4" name="Date Placeholder 3"/>
+          <p:cNvPr id="4" name="Date Placeholder 3">
+            <a:extLst>
+              <a:ext uri="{FF2B5EF4-FFF2-40B4-BE49-F238E27FC236}">
+                <a16:creationId xmlns:a16="http://schemas.microsoft.com/office/drawing/2014/main" id="{00A311B2-222B-4E2C-8BB1-F87D3AA08274}"/>
+              </a:ext>
+            </a:extLst>
+          </p:cNvPr>
           <p:cNvSpPr>
             <a:spLocks noGrp="1"/>
           </p:cNvSpPr>
@@ -476,9 +903,9 @@
           </a:bodyPr>
           <a:lstStyle/>
           <a:p>
-            <a:fld id="{E6744CE3-0875-4B69-89C0-6F72D8139561}" type="datetimeFigureOut">
+            <a:fld id="{EA9C4514-AD86-4E80-B6BC-BD70E0C475B2}" type="datetimeFigureOut">
               <a:rPr lang="en-GB" smtClean="0"/>
-              <a:t>26/05/17</a:t>
+              <a:t>29/09/2026</a:t>
             </a:fld>
             <a:endParaRPr lang="en-GB"/>
           </a:p>
@@ -486,7 +913,13 @@
       </p:sp>
       <p:sp>
         <p:nvSpPr>
-          <p:cNvPr id="5" name="Footer Placeholder 4"/>
+          <p:cNvPr id="5" name="Footer Placeholder 4">
+            <a:extLst>
+              <a:ext uri="{FF2B5EF4-FFF2-40B4-BE49-F238E27FC236}">
+                <a16:creationId xmlns:a16="http://schemas.microsoft.com/office/drawing/2014/main" id="{BA2DBC8A-2AF3-4593-92BD-A3969AD6FE91}"/>
+              </a:ext>
+            </a:extLst>
+          </p:cNvPr>
           <p:cNvSpPr>
             <a:spLocks noGrp="1"/>
           </p:cNvSpPr>
@@ -507,7 +940,13 @@
       </p:sp>
       <p:sp>
         <p:nvSpPr>
-          <p:cNvPr id="6" name="Slide Number Placeholder 5"/>
+          <p:cNvPr id="6" name="Slide Number Placeholder 5">
+            <a:extLst>
+              <a:ext uri="{FF2B5EF4-FFF2-40B4-BE49-F238E27FC236}">
+                <a16:creationId xmlns:a16="http://schemas.microsoft.com/office/drawing/2014/main" id="{5446C4D7-76D3-4915-86F1-956CE39864C9}"/>
+              </a:ext>
+            </a:extLst>
+          </p:cNvPr>
           <p:cNvSpPr>
             <a:spLocks noGrp="1"/>
           </p:cNvSpPr>
@@ -522,7 +961,7 @@
           </a:bodyPr>
           <a:lstStyle/>
           <a:p>
-            <a:fld id="{8DADB20D-508E-4C6D-A9E4-257D5607B0F6}" type="slidenum">
+            <a:fld id="{E3EE339C-4041-4A50-8D8F-1CA5E34F9F57}" type="slidenum">
               <a:rPr lang="en-GB" smtClean="0"/>
               <a:t>‹#›</a:t>
             </a:fld>
@@ -533,7 +972,7 @@
     </p:spTree>
     <p:extLst>
       <p:ext uri="{BB962C8B-B14F-4D97-AF65-F5344CB8AC3E}">
-        <p14:creationId xmlns:p14="http://schemas.microsoft.com/office/powerpoint/2010/main" val="271576982"/>
+        <p14:creationId xmlns:p14="http://schemas.microsoft.com/office/powerpoint/2010/main" val="4222692239"/>
       </p:ext>
     </p:extLst>
   </p:cSld>
@@ -562,7 +1001,13 @@
       </p:grpSpPr>
       <p:sp>
         <p:nvSpPr>
-          <p:cNvPr id="2" name="Title 1"/>
+          <p:cNvPr id="2" name="Title 1">
+            <a:extLst>
+              <a:ext uri="{FF2B5EF4-FFF2-40B4-BE49-F238E27FC236}">
+                <a16:creationId xmlns:a16="http://schemas.microsoft.com/office/drawing/2014/main" id="{19237A4D-98DE-4AB7-984C-934E77963922}"/>
+              </a:ext>
+            </a:extLst>
+          </p:cNvPr>
           <p:cNvSpPr>
             <a:spLocks noGrp="1"/>
           </p:cNvSpPr>
@@ -572,22 +1017,22 @@
         </p:nvSpPr>
         <p:spPr>
           <a:xfrm>
-            <a:off x="963084" y="4406900"/>
-            <a:ext cx="10363200" cy="1362075"/>
+            <a:off x="831850" y="1709738"/>
+            <a:ext cx="10515600" cy="2852737"/>
           </a:xfrm>
         </p:spPr>
         <p:txBody>
-          <a:bodyPr anchor="t">
+          <a:bodyPr anchor="b">
             <a:normAutofit xmlns:a="http://schemas.openxmlformats.org/drawingml/2006/main"/>
           </a:bodyPr>
           <a:lstStyle>
             <a:lvl1pPr algn="l">
-              <a:defRPr sz="4000" b="1" cap="all"/>
+              <a:defRPr sz="4000" b="1"/>
             </a:lvl1pPr>
           </a:lstStyle>
           <a:p>
             <a:r>
-              <a:rPr lang="en-US" smtClean="0"/>
+              <a:rPr lang="en-US"/>
               <a:t>Click to edit Master title style</a:t>
             </a:r>
             <a:endParaRPr lang="en-GB"/>
@@ -596,7 +1041,13 @@
       </p:sp>
       <p:sp>
         <p:nvSpPr>
-          <p:cNvPr id="3" name="Text Placeholder 2"/>
+          <p:cNvPr id="3" name="Text Placeholder 2">
+            <a:extLst>
+              <a:ext uri="{FF2B5EF4-FFF2-40B4-BE49-F238E27FC236}">
+                <a16:creationId xmlns:a16="http://schemas.microsoft.com/office/drawing/2014/main" id="{796F286A-5644-4B30-BFCD-794332D4CADD}"/>
+              </a:ext>
+            </a:extLst>
+          </p:cNvPr>
           <p:cNvSpPr>
             <a:spLocks noGrp="1"/>
           </p:cNvSpPr>
@@ -606,18 +1057,18 @@
         </p:nvSpPr>
         <p:spPr>
           <a:xfrm>
-            <a:off x="963084" y="2906713"/>
-            <a:ext cx="10363200" cy="1500187"/>
+            <a:off x="831850" y="4589463"/>
+            <a:ext cx="10515600" cy="1500187"/>
           </a:xfrm>
         </p:spPr>
         <p:txBody>
-          <a:bodyPr anchor="b">
+          <a:bodyPr>
             <a:normAutofit xmlns:a="http://schemas.openxmlformats.org/drawingml/2006/main"/>
           </a:bodyPr>
           <a:lstStyle>
             <a:lvl1pPr marL="0" indent="0">
               <a:buNone/>
-              <a:defRPr sz="2000">
+              <a:defRPr sz="2400">
                 <a:solidFill>
                   <a:schemeClr val="tx1">
                     <a:tint val="75000"/>
@@ -627,7 +1078,7 @@
             </a:lvl1pPr>
             <a:lvl2pPr marL="457200" indent="0">
               <a:buNone/>
-              <a:defRPr sz="1800">
+              <a:defRPr sz="2000">
                 <a:solidFill>
                   <a:schemeClr val="tx1">
                     <a:tint val="75000"/>
@@ -637,7 +1088,7 @@
             </a:lvl2pPr>
             <a:lvl3pPr marL="914400" indent="0">
               <a:buNone/>
-              <a:defRPr sz="1600">
+              <a:defRPr sz="1800">
                 <a:solidFill>
                   <a:schemeClr val="tx1">
                     <a:tint val="75000"/>
@@ -647,7 +1098,7 @@
             </a:lvl3pPr>
             <a:lvl4pPr marL="1371600" indent="0">
               <a:buNone/>
-              <a:defRPr sz="1400">
+              <a:defRPr sz="1600">
                 <a:solidFill>
                   <a:schemeClr val="tx1">
                     <a:tint val="75000"/>
@@ -657,7 +1108,7 @@
             </a:lvl4pPr>
             <a:lvl5pPr marL="1828800" indent="0">
               <a:buNone/>
-              <a:defRPr sz="1400">
+              <a:defRPr sz="1600">
                 <a:solidFill>
                   <a:schemeClr val="tx1">
                     <a:tint val="75000"/>
@@ -667,7 +1118,7 @@
             </a:lvl5pPr>
             <a:lvl6pPr marL="2286000" indent="0">
               <a:buNone/>
-              <a:defRPr sz="1400">
+              <a:defRPr sz="1600">
                 <a:solidFill>
                   <a:schemeClr val="tx1">
                     <a:tint val="75000"/>
@@ -677,7 +1128,7 @@
             </a:lvl6pPr>
             <a:lvl7pPr marL="2743200" indent="0">
               <a:buNone/>
-              <a:defRPr sz="1400">
+              <a:defRPr sz="1600">
                 <a:solidFill>
                   <a:schemeClr val="tx1">
                     <a:tint val="75000"/>
@@ -687,7 +1138,7 @@
             </a:lvl7pPr>
             <a:lvl8pPr marL="3200400" indent="0">
               <a:buNone/>
-              <a:defRPr sz="1400">
+              <a:defRPr sz="1600">
                 <a:solidFill>
                   <a:schemeClr val="tx1">
                     <a:tint val="75000"/>
@@ -697,7 +1148,7 @@
             </a:lvl8pPr>
             <a:lvl9pPr marL="3657600" indent="0">
               <a:buNone/>
-              <a:defRPr sz="1400">
+              <a:defRPr sz="1600">
                 <a:solidFill>
                   <a:schemeClr val="tx1">
                     <a:tint val="75000"/>
@@ -709,7 +1160,7 @@
           <a:p>
             <a:pPr lvl="0"/>
             <a:r>
-              <a:rPr lang="en-US" smtClean="0"/>
+              <a:rPr lang="en-US"/>
               <a:t>Click to edit Master text styles</a:t>
             </a:r>
           </a:p>
@@ -717,7 +1168,13 @@
       </p:sp>
       <p:sp>
         <p:nvSpPr>
-          <p:cNvPr id="4" name="Date Placeholder 3"/>
+          <p:cNvPr id="4" name="Date Placeholder 3">
+            <a:extLst>
+              <a:ext uri="{FF2B5EF4-FFF2-40B4-BE49-F238E27FC236}">
+                <a16:creationId xmlns:a16="http://schemas.microsoft.com/office/drawing/2014/main" id="{C514AF22-6B61-459E-B093-45B94EDDA9A4}"/>
+              </a:ext>
+            </a:extLst>
+          </p:cNvPr>
           <p:cNvSpPr>
             <a:spLocks noGrp="1"/>
           </p:cNvSpPr>
@@ -732,9 +1189,9 @@
           </a:bodyPr>
           <a:lstStyle/>
           <a:p>
-            <a:fld id="{E6744CE3-0875-4B69-89C0-6F72D8139561}" type="datetimeFigureOut">
+            <a:fld id="{EA9C4514-AD86-4E80-B6BC-BD70E0C475B2}" type="datetimeFigureOut">
               <a:rPr lang="en-GB" smtClean="0"/>
-              <a:t>26/05/17</a:t>
+              <a:t>29/09/2026</a:t>
             </a:fld>
             <a:endParaRPr lang="en-GB"/>
           </a:p>
@@ -742,7 +1199,13 @@
       </p:sp>
       <p:sp>
         <p:nvSpPr>
-          <p:cNvPr id="5" name="Footer Placeholder 4"/>
+          <p:cNvPr id="5" name="Footer Placeholder 4">
+            <a:extLst>
+              <a:ext uri="{FF2B5EF4-FFF2-40B4-BE49-F238E27FC236}">
+                <a16:creationId xmlns:a16="http://schemas.microsoft.com/office/drawing/2014/main" id="{D1497645-0ABF-4688-92D5-B757D54581E4}"/>
+              </a:ext>
+            </a:extLst>
+          </p:cNvPr>
           <p:cNvSpPr>
             <a:spLocks noGrp="1"/>
           </p:cNvSpPr>
@@ -763,7 +1226,13 @@
       </p:sp>
       <p:sp>
         <p:nvSpPr>
-          <p:cNvPr id="6" name="Slide Number Placeholder 5"/>
+          <p:cNvPr id="6" name="Slide Number Placeholder 5">
+            <a:extLst>
+              <a:ext uri="{FF2B5EF4-FFF2-40B4-BE49-F238E27FC236}">
+                <a16:creationId xmlns:a16="http://schemas.microsoft.com/office/drawing/2014/main" id="{D774284C-8955-4EDB-9398-C8E3F602F378}"/>
+              </a:ext>
+            </a:extLst>
+          </p:cNvPr>
           <p:cNvSpPr>
             <a:spLocks noGrp="1"/>
           </p:cNvSpPr>
@@ -778,7 +1247,7 @@
           </a:bodyPr>
           <a:lstStyle/>
           <a:p>
-            <a:fld id="{8DADB20D-508E-4C6D-A9E4-257D5607B0F6}" type="slidenum">
+            <a:fld id="{E3EE339C-4041-4A50-8D8F-1CA5E34F9F57}" type="slidenum">
               <a:rPr lang="en-GB" smtClean="0"/>
               <a:t>‹#›</a:t>
             </a:fld>
@@ -789,7 +1258,7 @@
     </p:spTree>
     <p:extLst>
       <p:ext uri="{BB962C8B-B14F-4D97-AF65-F5344CB8AC3E}">
-        <p14:creationId xmlns:p14="http://schemas.microsoft.com/office/powerpoint/2010/main" val="1431545585"/>
+        <p14:creationId xmlns:p14="http://schemas.microsoft.com/office/powerpoint/2010/main" val="2631461907"/>
       </p:ext>
     </p:extLst>
   </p:cSld>
@@ -818,7 +1287,13 @@
       </p:grpSpPr>
       <p:sp>
         <p:nvSpPr>
-          <p:cNvPr id="2" name="Title 1"/>
+          <p:cNvPr id="2" name="Title 1">
+            <a:extLst>
+              <a:ext uri="{FF2B5EF4-FFF2-40B4-BE49-F238E27FC236}">
+                <a16:creationId xmlns:a16="http://schemas.microsoft.com/office/drawing/2014/main" id="{6F543D6A-53E8-411F-B4F7-AA044B26DD01}"/>
+              </a:ext>
+            </a:extLst>
+          </p:cNvPr>
           <p:cNvSpPr>
             <a:spLocks noGrp="1"/>
           </p:cNvSpPr>
@@ -834,7 +1309,7 @@
           <a:lstStyle/>
           <a:p>
             <a:r>
-              <a:rPr lang="en-US" smtClean="0"/>
+              <a:rPr lang="en-US"/>
               <a:t>Click to edit Master title style</a:t>
             </a:r>
             <a:endParaRPr lang="en-GB"/>
@@ -843,7 +1318,13 @@
       </p:sp>
       <p:sp>
         <p:nvSpPr>
-          <p:cNvPr id="3" name="Content Placeholder 2"/>
+          <p:cNvPr id="3" name="Content Placeholder 2">
+            <a:extLst>
+              <a:ext uri="{FF2B5EF4-FFF2-40B4-BE49-F238E27FC236}">
+                <a16:creationId xmlns:a16="http://schemas.microsoft.com/office/drawing/2014/main" id="{406DA655-1E66-4219-93BF-031E10A68CDA}"/>
+              </a:ext>
+            </a:extLst>
+          </p:cNvPr>
           <p:cNvSpPr>
             <a:spLocks noGrp="1"/>
           </p:cNvSpPr>
@@ -853,75 +1334,47 @@
         </p:nvSpPr>
         <p:spPr>
           <a:xfrm>
-            <a:off x="609600" y="1600200"/>
-            <a:ext cx="5384800" cy="4525963"/>
+            <a:off x="838200" y="1825625"/>
+            <a:ext cx="5181600" cy="4351338"/>
           </a:xfrm>
         </p:spPr>
         <p:txBody>
           <a:bodyPr>
             <a:normAutofit xmlns:a="http://schemas.openxmlformats.org/drawingml/2006/main"/>
           </a:bodyPr>
-          <a:lstStyle>
-            <a:lvl1pPr>
-              <a:defRPr sz="2800"/>
-            </a:lvl1pPr>
-            <a:lvl2pPr>
-              <a:defRPr sz="2400"/>
-            </a:lvl2pPr>
-            <a:lvl3pPr>
-              <a:defRPr sz="2000"/>
-            </a:lvl3pPr>
-            <a:lvl4pPr>
-              <a:defRPr sz="1800"/>
-            </a:lvl4pPr>
-            <a:lvl5pPr>
-              <a:defRPr sz="1800"/>
-            </a:lvl5pPr>
-            <a:lvl6pPr>
-              <a:defRPr sz="1800"/>
-            </a:lvl6pPr>
-            <a:lvl7pPr>
-              <a:defRPr sz="1800"/>
-            </a:lvl7pPr>
-            <a:lvl8pPr>
-              <a:defRPr sz="1800"/>
-            </a:lvl8pPr>
-            <a:lvl9pPr>
-              <a:defRPr sz="1800"/>
-            </a:lvl9pPr>
-          </a:lstStyle>
+          <a:lstStyle/>
           <a:p>
             <a:pPr lvl="0"/>
             <a:r>
-              <a:rPr lang="en-US" smtClean="0"/>
+              <a:rPr lang="en-US"/>
               <a:t>Click to edit Master text styles</a:t>
             </a:r>
           </a:p>
           <a:p>
             <a:pPr lvl="1"/>
             <a:r>
-              <a:rPr lang="en-US" smtClean="0"/>
+              <a:rPr lang="en-US"/>
               <a:t>Second level</a:t>
             </a:r>
           </a:p>
           <a:p>
             <a:pPr lvl="2"/>
             <a:r>
-              <a:rPr lang="en-US" smtClean="0"/>
+              <a:rPr lang="en-US"/>
               <a:t>Third level</a:t>
             </a:r>
           </a:p>
           <a:p>
             <a:pPr lvl="3"/>
             <a:r>
-              <a:rPr lang="en-US" smtClean="0"/>
+              <a:rPr lang="en-US"/>
               <a:t>Fourth level</a:t>
             </a:r>
           </a:p>
           <a:p>
             <a:pPr lvl="4"/>
             <a:r>
-              <a:rPr lang="en-US" smtClean="0"/>
+              <a:rPr lang="en-US"/>
               <a:t>Fifth level</a:t>
             </a:r>
             <a:endParaRPr lang="en-GB"/>
@@ -930,7 +1383,13 @@
       </p:sp>
       <p:sp>
         <p:nvSpPr>
-          <p:cNvPr id="4" name="Content Placeholder 3"/>
+          <p:cNvPr id="4" name="Content Placeholder 3">
+            <a:extLst>
+              <a:ext uri="{FF2B5EF4-FFF2-40B4-BE49-F238E27FC236}">
+                <a16:creationId xmlns:a16="http://schemas.microsoft.com/office/drawing/2014/main" id="{9BB0D788-703A-4706-B064-DF7B627D1282}"/>
+              </a:ext>
+            </a:extLst>
+          </p:cNvPr>
           <p:cNvSpPr>
             <a:spLocks noGrp="1"/>
           </p:cNvSpPr>
@@ -940,75 +1399,47 @@
         </p:nvSpPr>
         <p:spPr>
           <a:xfrm>
-            <a:off x="6197600" y="1600200"/>
-            <a:ext cx="5384800" cy="4525963"/>
+            <a:off x="6172200" y="1825625"/>
+            <a:ext cx="5181600" cy="4351338"/>
           </a:xfrm>
         </p:spPr>
         <p:txBody>
           <a:bodyPr>
             <a:normAutofit xmlns:a="http://schemas.openxmlformats.org/drawingml/2006/main"/>
           </a:bodyPr>
-          <a:lstStyle>
-            <a:lvl1pPr>
-              <a:defRPr sz="2800"/>
-            </a:lvl1pPr>
-            <a:lvl2pPr>
-              <a:defRPr sz="2400"/>
-            </a:lvl2pPr>
-            <a:lvl3pPr>
-              <a:defRPr sz="2000"/>
-            </a:lvl3pPr>
-            <a:lvl4pPr>
-              <a:defRPr sz="1800"/>
-            </a:lvl4pPr>
-            <a:lvl5pPr>
-              <a:defRPr sz="1800"/>
-            </a:lvl5pPr>
-            <a:lvl6pPr>
-              <a:defRPr sz="1800"/>
-            </a:lvl6pPr>
-            <a:lvl7pPr>
-              <a:defRPr sz="1800"/>
-            </a:lvl7pPr>
-            <a:lvl8pPr>
-              <a:defRPr sz="1800"/>
-            </a:lvl8pPr>
-            <a:lvl9pPr>
-              <a:defRPr sz="1800"/>
-            </a:lvl9pPr>
-          </a:lstStyle>
+          <a:lstStyle/>
           <a:p>
             <a:pPr lvl="0"/>
             <a:r>
-              <a:rPr lang="en-US" smtClean="0"/>
+              <a:rPr lang="en-US"/>
               <a:t>Click to edit Master text styles</a:t>
             </a:r>
           </a:p>
           <a:p>
             <a:pPr lvl="1"/>
             <a:r>
-              <a:rPr lang="en-US" smtClean="0"/>
+              <a:rPr lang="en-US"/>
               <a:t>Second level</a:t>
             </a:r>
           </a:p>
           <a:p>
             <a:pPr lvl="2"/>
             <a:r>
-              <a:rPr lang="en-US" smtClean="0"/>
+              <a:rPr lang="en-US"/>
               <a:t>Third level</a:t>
             </a:r>
           </a:p>
           <a:p>
             <a:pPr lvl="3"/>
             <a:r>
-              <a:rPr lang="en-US" smtClean="0"/>
+              <a:rPr lang="en-US"/>
               <a:t>Fourth level</a:t>
             </a:r>
           </a:p>
           <a:p>
             <a:pPr lvl="4"/>
             <a:r>
-              <a:rPr lang="en-US" smtClean="0"/>
+              <a:rPr lang="en-US"/>
               <a:t>Fifth level</a:t>
             </a:r>
             <a:endParaRPr lang="en-GB"/>
@@ -1017,7 +1448,13 @@
       </p:sp>
       <p:sp>
         <p:nvSpPr>
-          <p:cNvPr id="5" name="Date Placeholder 4"/>
+          <p:cNvPr id="5" name="Date Placeholder 4">
+            <a:extLst>
+              <a:ext uri="{FF2B5EF4-FFF2-40B4-BE49-F238E27FC236}">
+                <a16:creationId xmlns:a16="http://schemas.microsoft.com/office/drawing/2014/main" id="{0563C22F-5E26-4FA0-B7AD-50A9FD88F663}"/>
+              </a:ext>
+            </a:extLst>
+          </p:cNvPr>
           <p:cNvSpPr>
             <a:spLocks noGrp="1"/>
           </p:cNvSpPr>
@@ -1032,9 +1469,9 @@
           </a:bodyPr>
           <a:lstStyle/>
           <a:p>
-            <a:fld id="{E6744CE3-0875-4B69-89C0-6F72D8139561}" type="datetimeFigureOut">
+            <a:fld id="{EA9C4514-AD86-4E80-B6BC-BD70E0C475B2}" type="datetimeFigureOut">
               <a:rPr lang="en-GB" smtClean="0"/>
-              <a:t>26/05/17</a:t>
+              <a:t>29/09/2026</a:t>
             </a:fld>
             <a:endParaRPr lang="en-GB"/>
           </a:p>
@@ -1042,7 +1479,13 @@
       </p:sp>
       <p:sp>
         <p:nvSpPr>
-          <p:cNvPr id="6" name="Footer Placeholder 5"/>
+          <p:cNvPr id="6" name="Footer Placeholder 5">
+            <a:extLst>
+              <a:ext uri="{FF2B5EF4-FFF2-40B4-BE49-F238E27FC236}">
+                <a16:creationId xmlns:a16="http://schemas.microsoft.com/office/drawing/2014/main" id="{B3CD40B3-F592-4848-9597-C8CC4865F161}"/>
+              </a:ext>
+            </a:extLst>
+          </p:cNvPr>
           <p:cNvSpPr>
             <a:spLocks noGrp="1"/>
           </p:cNvSpPr>
@@ -1063,7 +1506,13 @@
       </p:sp>
       <p:sp>
         <p:nvSpPr>
-          <p:cNvPr id="7" name="Slide Number Placeholder 6"/>
+          <p:cNvPr id="7" name="Slide Number Placeholder 6">
+            <a:extLst>
+              <a:ext uri="{FF2B5EF4-FFF2-40B4-BE49-F238E27FC236}">
+                <a16:creationId xmlns:a16="http://schemas.microsoft.com/office/drawing/2014/main" id="{C801661A-5DAF-4BA3-B2C7-8D2C75DF3158}"/>
+              </a:ext>
+            </a:extLst>
+          </p:cNvPr>
           <p:cNvSpPr>
             <a:spLocks noGrp="1"/>
           </p:cNvSpPr>
@@ -1078,7 +1527,7 @@
           </a:bodyPr>
           <a:lstStyle/>
           <a:p>
-            <a:fld id="{8DADB20D-508E-4C6D-A9E4-257D5607B0F6}" type="slidenum">
+            <a:fld id="{E3EE339C-4041-4A50-8D8F-1CA5E34F9F57}" type="slidenum">
               <a:rPr lang="en-GB" smtClean="0"/>
               <a:t>‹#›</a:t>
             </a:fld>
@@ -1089,7 +1538,7 @@
     </p:spTree>
     <p:extLst>
       <p:ext uri="{BB962C8B-B14F-4D97-AF65-F5344CB8AC3E}">
-        <p14:creationId xmlns:p14="http://schemas.microsoft.com/office/powerpoint/2010/main" val="468392282"/>
+        <p14:creationId xmlns:p14="http://schemas.microsoft.com/office/powerpoint/2010/main" val="4265277706"/>
       </p:ext>
     </p:extLst>
   </p:cSld>
@@ -1118,47 +1567,60 @@
       </p:grpSpPr>
       <p:sp>
         <p:nvSpPr>
-          <p:cNvPr id="2" name="Title 1"/>
+          <p:cNvPr id="2" name="Title 1">
+            <a:extLst>
+              <a:ext uri="{FF2B5EF4-FFF2-40B4-BE49-F238E27FC236}">
+                <a16:creationId xmlns:a16="http://schemas.microsoft.com/office/drawing/2014/main" id="{899E96E3-2CDE-49BE-8525-C88C850447DE}"/>
+              </a:ext>
+            </a:extLst>
+          </p:cNvPr>
           <p:cNvSpPr>
             <a:spLocks noGrp="1"/>
           </p:cNvSpPr>
           <p:nvPr>
             <p:ph type="title"/>
-          </p:nvPr>
-        </p:nvSpPr>
-        <p:spPr/>
-        <p:txBody>
-          <a:bodyPr>
-            <a:normAutofit xmlns:a="http://schemas.openxmlformats.org/drawingml/2006/main"/>
-          </a:bodyPr>
-          <a:lstStyle>
-            <a:lvl1pPr>
-              <a:defRPr/>
-            </a:lvl1pPr>
-          </a:lstStyle>
-          <a:p>
-            <a:r>
-              <a:rPr lang="en-US" smtClean="0"/>
-              <a:t>Click to edit Master title style</a:t>
-            </a:r>
-            <a:endParaRPr lang="en-GB"/>
-          </a:p>
-        </p:txBody>
-      </p:sp>
-      <p:sp>
-        <p:nvSpPr>
-          <p:cNvPr id="3" name="Text Placeholder 2"/>
-          <p:cNvSpPr>
-            <a:spLocks noGrp="1"/>
-          </p:cNvSpPr>
-          <p:nvPr>
-            <p:ph type="body" idx="1"/>
           </p:nvPr>
         </p:nvSpPr>
         <p:spPr>
           <a:xfrm>
-            <a:off x="609600" y="1535113"/>
-            <a:ext cx="5386917" cy="639762"/>
+            <a:off x="839788" y="365125"/>
+            <a:ext cx="10515600" cy="1325563"/>
+          </a:xfrm>
+        </p:spPr>
+        <p:txBody>
+          <a:bodyPr>
+            <a:normAutofit xmlns:a="http://schemas.openxmlformats.org/drawingml/2006/main"/>
+          </a:bodyPr>
+          <a:lstStyle/>
+          <a:p>
+            <a:r>
+              <a:rPr lang="en-US"/>
+              <a:t>Click to edit Master title style</a:t>
+            </a:r>
+            <a:endParaRPr lang="en-GB"/>
+          </a:p>
+        </p:txBody>
+      </p:sp>
+      <p:sp>
+        <p:nvSpPr>
+          <p:cNvPr id="3" name="Text Placeholder 2">
+            <a:extLst>
+              <a:ext uri="{FF2B5EF4-FFF2-40B4-BE49-F238E27FC236}">
+                <a16:creationId xmlns:a16="http://schemas.microsoft.com/office/drawing/2014/main" id="{49863AB4-8DC1-4A74-8673-8EEDAFD3CB40}"/>
+              </a:ext>
+            </a:extLst>
+          </p:cNvPr>
+          <p:cNvSpPr>
+            <a:spLocks noGrp="1"/>
+          </p:cNvSpPr>
+          <p:nvPr>
+            <p:ph type="body" idx="1"/>
+          </p:nvPr>
+        </p:nvSpPr>
+        <p:spPr>
+          <a:xfrm>
+            <a:off x="839788" y="1681163"/>
+            <a:ext cx="5157787" cy="823912"/>
           </a:xfrm>
         </p:spPr>
         <p:txBody>
@@ -1206,7 +1668,7 @@
           <a:p>
             <a:pPr lvl="0"/>
             <a:r>
-              <a:rPr lang="en-US" smtClean="0"/>
+              <a:rPr lang="en-US"/>
               <a:t>Click to edit Master text styles</a:t>
             </a:r>
           </a:p>
@@ -1214,7 +1676,13 @@
       </p:sp>
       <p:sp>
         <p:nvSpPr>
-          <p:cNvPr id="4" name="Content Placeholder 3"/>
+          <p:cNvPr id="4" name="Content Placeholder 3">
+            <a:extLst>
+              <a:ext uri="{FF2B5EF4-FFF2-40B4-BE49-F238E27FC236}">
+                <a16:creationId xmlns:a16="http://schemas.microsoft.com/office/drawing/2014/main" id="{DAE4682D-2DFE-4F81-9546-5DED133F7884}"/>
+              </a:ext>
+            </a:extLst>
+          </p:cNvPr>
           <p:cNvSpPr>
             <a:spLocks noGrp="1"/>
           </p:cNvSpPr>
@@ -1224,75 +1692,47 @@
         </p:nvSpPr>
         <p:spPr>
           <a:xfrm>
-            <a:off x="609600" y="2174875"/>
-            <a:ext cx="5386917" cy="3951288"/>
+            <a:off x="839788" y="2505075"/>
+            <a:ext cx="5157787" cy="3684588"/>
           </a:xfrm>
         </p:spPr>
         <p:txBody>
           <a:bodyPr>
             <a:normAutofit xmlns:a="http://schemas.openxmlformats.org/drawingml/2006/main"/>
           </a:bodyPr>
-          <a:lstStyle>
-            <a:lvl1pPr>
-              <a:defRPr sz="2400"/>
-            </a:lvl1pPr>
-            <a:lvl2pPr>
-              <a:defRPr sz="2000"/>
-            </a:lvl2pPr>
-            <a:lvl3pPr>
-              <a:defRPr sz="1800"/>
-            </a:lvl3pPr>
-            <a:lvl4pPr>
-              <a:defRPr sz="1600"/>
-            </a:lvl4pPr>
-            <a:lvl5pPr>
-              <a:defRPr sz="1600"/>
-            </a:lvl5pPr>
-            <a:lvl6pPr>
-              <a:defRPr sz="1600"/>
-            </a:lvl6pPr>
-            <a:lvl7pPr>
-              <a:defRPr sz="1600"/>
-            </a:lvl7pPr>
-            <a:lvl8pPr>
-              <a:defRPr sz="1600"/>
-            </a:lvl8pPr>
-            <a:lvl9pPr>
-              <a:defRPr sz="1600"/>
-            </a:lvl9pPr>
-          </a:lstStyle>
+          <a:lstStyle/>
           <a:p>
             <a:pPr lvl="0"/>
             <a:r>
-              <a:rPr lang="en-US" smtClean="0"/>
+              <a:rPr lang="en-US"/>
               <a:t>Click to edit Master text styles</a:t>
             </a:r>
           </a:p>
           <a:p>
             <a:pPr lvl="1"/>
             <a:r>
-              <a:rPr lang="en-US" smtClean="0"/>
+              <a:rPr lang="en-US"/>
               <a:t>Second level</a:t>
             </a:r>
           </a:p>
           <a:p>
             <a:pPr lvl="2"/>
             <a:r>
-              <a:rPr lang="en-US" smtClean="0"/>
+              <a:rPr lang="en-US"/>
               <a:t>Third level</a:t>
             </a:r>
           </a:p>
           <a:p>
             <a:pPr lvl="3"/>
             <a:r>
-              <a:rPr lang="en-US" smtClean="0"/>
+              <a:rPr lang="en-US"/>
               <a:t>Fourth level</a:t>
             </a:r>
           </a:p>
           <a:p>
             <a:pPr lvl="4"/>
             <a:r>
-              <a:rPr lang="en-US" smtClean="0"/>
+              <a:rPr lang="en-US"/>
               <a:t>Fifth level</a:t>
             </a:r>
             <a:endParaRPr lang="en-GB"/>
@@ -1301,7 +1741,13 @@
       </p:sp>
       <p:sp>
         <p:nvSpPr>
-          <p:cNvPr id="5" name="Text Placeholder 4"/>
+          <p:cNvPr id="5" name="Text Placeholder 4">
+            <a:extLst>
+              <a:ext uri="{FF2B5EF4-FFF2-40B4-BE49-F238E27FC236}">
+                <a16:creationId xmlns:a16="http://schemas.microsoft.com/office/drawing/2014/main" id="{CB914F1B-1B6B-4956-831C-130E33869017}"/>
+              </a:ext>
+            </a:extLst>
+          </p:cNvPr>
           <p:cNvSpPr>
             <a:spLocks noGrp="1"/>
           </p:cNvSpPr>
@@ -1311,8 +1757,8 @@
         </p:nvSpPr>
         <p:spPr>
           <a:xfrm>
-            <a:off x="6193367" y="1535113"/>
-            <a:ext cx="5389033" cy="639762"/>
+            <a:off x="6172200" y="1681163"/>
+            <a:ext cx="5183188" cy="823912"/>
           </a:xfrm>
         </p:spPr>
         <p:txBody>
@@ -1360,7 +1806,7 @@
           <a:p>
             <a:pPr lvl="0"/>
             <a:r>
-              <a:rPr lang="en-US" smtClean="0"/>
+              <a:rPr lang="en-US"/>
               <a:t>Click to edit Master text styles</a:t>
             </a:r>
           </a:p>
@@ -1368,7 +1814,13 @@
       </p:sp>
       <p:sp>
         <p:nvSpPr>
-          <p:cNvPr id="6" name="Content Placeholder 5"/>
+          <p:cNvPr id="6" name="Content Placeholder 5">
+            <a:extLst>
+              <a:ext uri="{FF2B5EF4-FFF2-40B4-BE49-F238E27FC236}">
+                <a16:creationId xmlns:a16="http://schemas.microsoft.com/office/drawing/2014/main" id="{DB0F3CF6-7945-4381-997A-560E9EE9BFB1}"/>
+              </a:ext>
+            </a:extLst>
+          </p:cNvPr>
           <p:cNvSpPr>
             <a:spLocks noGrp="1"/>
           </p:cNvSpPr>
@@ -1378,75 +1830,47 @@
         </p:nvSpPr>
         <p:spPr>
           <a:xfrm>
-            <a:off x="6193367" y="2174875"/>
-            <a:ext cx="5389033" cy="3951288"/>
+            <a:off x="6172200" y="2505075"/>
+            <a:ext cx="5183188" cy="3684588"/>
           </a:xfrm>
         </p:spPr>
         <p:txBody>
           <a:bodyPr>
             <a:normAutofit xmlns:a="http://schemas.openxmlformats.org/drawingml/2006/main"/>
           </a:bodyPr>
-          <a:lstStyle>
-            <a:lvl1pPr>
-              <a:defRPr sz="2400"/>
-            </a:lvl1pPr>
-            <a:lvl2pPr>
-              <a:defRPr sz="2000"/>
-            </a:lvl2pPr>
-            <a:lvl3pPr>
-              <a:defRPr sz="1800"/>
-            </a:lvl3pPr>
-            <a:lvl4pPr>
-              <a:defRPr sz="1600"/>
-            </a:lvl4pPr>
-            <a:lvl5pPr>
-              <a:defRPr sz="1600"/>
-            </a:lvl5pPr>
-            <a:lvl6pPr>
-              <a:defRPr sz="1600"/>
-            </a:lvl6pPr>
-            <a:lvl7pPr>
-              <a:defRPr sz="1600"/>
-            </a:lvl7pPr>
-            <a:lvl8pPr>
-              <a:defRPr sz="1600"/>
-            </a:lvl8pPr>
-            <a:lvl9pPr>
-              <a:defRPr sz="1600"/>
-            </a:lvl9pPr>
-          </a:lstStyle>
+          <a:lstStyle/>
           <a:p>
             <a:pPr lvl="0"/>
             <a:r>
-              <a:rPr lang="en-US" smtClean="0"/>
+              <a:rPr lang="en-US"/>
               <a:t>Click to edit Master text styles</a:t>
             </a:r>
           </a:p>
           <a:p>
             <a:pPr lvl="1"/>
             <a:r>
-              <a:rPr lang="en-US" smtClean="0"/>
+              <a:rPr lang="en-US"/>
               <a:t>Second level</a:t>
             </a:r>
           </a:p>
           <a:p>
             <a:pPr lvl="2"/>
             <a:r>
-              <a:rPr lang="en-US" smtClean="0"/>
+              <a:rPr lang="en-US"/>
               <a:t>Third level</a:t>
             </a:r>
           </a:p>
           <a:p>
             <a:pPr lvl="3"/>
             <a:r>
-              <a:rPr lang="en-US" smtClean="0"/>
+              <a:rPr lang="en-US"/>
               <a:t>Fourth level</a:t>
             </a:r>
           </a:p>
           <a:p>
             <a:pPr lvl="4"/>
             <a:r>
-              <a:rPr lang="en-US" smtClean="0"/>
+              <a:rPr lang="en-US"/>
               <a:t>Fifth level</a:t>
             </a:r>
             <a:endParaRPr lang="en-GB"/>
@@ -1455,7 +1879,13 @@
       </p:sp>
       <p:sp>
         <p:nvSpPr>
-          <p:cNvPr id="7" name="Date Placeholder 6"/>
+          <p:cNvPr id="7" name="Date Placeholder 6">
+            <a:extLst>
+              <a:ext uri="{FF2B5EF4-FFF2-40B4-BE49-F238E27FC236}">
+                <a16:creationId xmlns:a16="http://schemas.microsoft.com/office/drawing/2014/main" id="{CCB27693-A63F-4624-AAA2-A5D53643A682}"/>
+              </a:ext>
+            </a:extLst>
+          </p:cNvPr>
           <p:cNvSpPr>
             <a:spLocks noGrp="1"/>
           </p:cNvSpPr>
@@ -1470,9 +1900,9 @@
           </a:bodyPr>
           <a:lstStyle/>
           <a:p>
-            <a:fld id="{E6744CE3-0875-4B69-89C0-6F72D8139561}" type="datetimeFigureOut">
+            <a:fld id="{EA9C4514-AD86-4E80-B6BC-BD70E0C475B2}" type="datetimeFigureOut">
               <a:rPr lang="en-GB" smtClean="0"/>
-              <a:t>26/05/17</a:t>
+              <a:t>29/09/2026</a:t>
             </a:fld>
             <a:endParaRPr lang="en-GB"/>
           </a:p>
@@ -1480,7 +1910,13 @@
       </p:sp>
       <p:sp>
         <p:nvSpPr>
-          <p:cNvPr id="8" name="Footer Placeholder 7"/>
+          <p:cNvPr id="8" name="Footer Placeholder 7">
+            <a:extLst>
+              <a:ext uri="{FF2B5EF4-FFF2-40B4-BE49-F238E27FC236}">
+                <a16:creationId xmlns:a16="http://schemas.microsoft.com/office/drawing/2014/main" id="{8BA48A31-5593-4445-9311-617B929DC93C}"/>
+              </a:ext>
+            </a:extLst>
+          </p:cNvPr>
           <p:cNvSpPr>
             <a:spLocks noGrp="1"/>
           </p:cNvSpPr>
@@ -1501,7 +1937,13 @@
       </p:sp>
       <p:sp>
         <p:nvSpPr>
-          <p:cNvPr id="9" name="Slide Number Placeholder 8"/>
+          <p:cNvPr id="9" name="Slide Number Placeholder 8">
+            <a:extLst>
+              <a:ext uri="{FF2B5EF4-FFF2-40B4-BE49-F238E27FC236}">
+                <a16:creationId xmlns:a16="http://schemas.microsoft.com/office/drawing/2014/main" id="{47196A62-8DD0-4033-B4E3-8D7FAE8CFAD9}"/>
+              </a:ext>
+            </a:extLst>
+          </p:cNvPr>
           <p:cNvSpPr>
             <a:spLocks noGrp="1"/>
           </p:cNvSpPr>
@@ -1516,7 +1958,7 @@
           </a:bodyPr>
           <a:lstStyle/>
           <a:p>
-            <a:fld id="{8DADB20D-508E-4C6D-A9E4-257D5607B0F6}" type="slidenum">
+            <a:fld id="{E3EE339C-4041-4A50-8D8F-1CA5E34F9F57}" type="slidenum">
               <a:rPr lang="en-GB" smtClean="0"/>
               <a:t>‹#›</a:t>
             </a:fld>
@@ -1527,7 +1969,7 @@
     </p:spTree>
     <p:extLst>
       <p:ext uri="{BB962C8B-B14F-4D97-AF65-F5344CB8AC3E}">
-        <p14:creationId xmlns:p14="http://schemas.microsoft.com/office/powerpoint/2010/main" val="2120349123"/>
+        <p14:creationId xmlns:p14="http://schemas.microsoft.com/office/powerpoint/2010/main" val="1266956987"/>
       </p:ext>
     </p:extLst>
   </p:cSld>
@@ -1556,7 +1998,13 @@
       </p:grpSpPr>
       <p:sp>
         <p:nvSpPr>
-          <p:cNvPr id="2" name="Title 1"/>
+          <p:cNvPr id="2" name="Title 1">
+            <a:extLst>
+              <a:ext uri="{FF2B5EF4-FFF2-40B4-BE49-F238E27FC236}">
+                <a16:creationId xmlns:a16="http://schemas.microsoft.com/office/drawing/2014/main" id="{1EDADA6A-AC9F-4D78-9128-E94328F211CB}"/>
+              </a:ext>
+            </a:extLst>
+          </p:cNvPr>
           <p:cNvSpPr>
             <a:spLocks noGrp="1"/>
           </p:cNvSpPr>
@@ -1572,7 +2020,7 @@
           <a:lstStyle/>
           <a:p>
             <a:r>
-              <a:rPr lang="en-US" smtClean="0"/>
+              <a:rPr lang="en-US"/>
               <a:t>Click to edit Master title style</a:t>
             </a:r>
             <a:endParaRPr lang="en-GB"/>
@@ -1581,7 +2029,13 @@
       </p:sp>
       <p:sp>
         <p:nvSpPr>
-          <p:cNvPr id="3" name="Date Placeholder 2"/>
+          <p:cNvPr id="3" name="Date Placeholder 2">
+            <a:extLst>
+              <a:ext uri="{FF2B5EF4-FFF2-40B4-BE49-F238E27FC236}">
+                <a16:creationId xmlns:a16="http://schemas.microsoft.com/office/drawing/2014/main" id="{0EA94D76-9B50-400E-923A-2B650C8730AA}"/>
+              </a:ext>
+            </a:extLst>
+          </p:cNvPr>
           <p:cNvSpPr>
             <a:spLocks noGrp="1"/>
           </p:cNvSpPr>
@@ -1596,9 +2050,9 @@
           </a:bodyPr>
           <a:lstStyle/>
           <a:p>
-            <a:fld id="{E6744CE3-0875-4B69-89C0-6F72D8139561}" type="datetimeFigureOut">
+            <a:fld id="{EA9C4514-AD86-4E80-B6BC-BD70E0C475B2}" type="datetimeFigureOut">
               <a:rPr lang="en-GB" smtClean="0"/>
-              <a:t>26/05/17</a:t>
+              <a:t>29/09/2026</a:t>
             </a:fld>
             <a:endParaRPr lang="en-GB"/>
           </a:p>
@@ -1606,7 +2060,13 @@
       </p:sp>
       <p:sp>
         <p:nvSpPr>
-          <p:cNvPr id="4" name="Footer Placeholder 3"/>
+          <p:cNvPr id="4" name="Footer Placeholder 3">
+            <a:extLst>
+              <a:ext uri="{FF2B5EF4-FFF2-40B4-BE49-F238E27FC236}">
+                <a16:creationId xmlns:a16="http://schemas.microsoft.com/office/drawing/2014/main" id="{3527DB90-7ACD-4CD9-A006-67E3CB1F3849}"/>
+              </a:ext>
+            </a:extLst>
+          </p:cNvPr>
           <p:cNvSpPr>
             <a:spLocks noGrp="1"/>
           </p:cNvSpPr>
@@ -1627,7 +2087,13 @@
       </p:sp>
       <p:sp>
         <p:nvSpPr>
-          <p:cNvPr id="5" name="Slide Number Placeholder 4"/>
+          <p:cNvPr id="5" name="Slide Number Placeholder 4">
+            <a:extLst>
+              <a:ext uri="{FF2B5EF4-FFF2-40B4-BE49-F238E27FC236}">
+                <a16:creationId xmlns:a16="http://schemas.microsoft.com/office/drawing/2014/main" id="{51BD58EC-762B-4807-8805-AC5871B798B7}"/>
+              </a:ext>
+            </a:extLst>
+          </p:cNvPr>
           <p:cNvSpPr>
             <a:spLocks noGrp="1"/>
           </p:cNvSpPr>
@@ -1642,7 +2108,7 @@
           </a:bodyPr>
           <a:lstStyle/>
           <a:p>
-            <a:fld id="{8DADB20D-508E-4C6D-A9E4-257D5607B0F6}" type="slidenum">
+            <a:fld id="{E3EE339C-4041-4A50-8D8F-1CA5E34F9F57}" type="slidenum">
               <a:rPr lang="en-GB" smtClean="0"/>
               <a:t>‹#›</a:t>
             </a:fld>
@@ -1653,7 +2119,7 @@
     </p:spTree>
     <p:extLst>
       <p:ext uri="{BB962C8B-B14F-4D97-AF65-F5344CB8AC3E}">
-        <p14:creationId xmlns:p14="http://schemas.microsoft.com/office/powerpoint/2010/main" val="1385807973"/>
+        <p14:creationId xmlns:p14="http://schemas.microsoft.com/office/powerpoint/2010/main" val="917757018"/>
       </p:ext>
     </p:extLst>
   </p:cSld>
@@ -1682,7 +2148,13 @@
       </p:grpSpPr>
       <p:sp>
         <p:nvSpPr>
-          <p:cNvPr id="2" name="Date Placeholder 1"/>
+          <p:cNvPr id="2" name="Date Placeholder 1">
+            <a:extLst>
+              <a:ext uri="{FF2B5EF4-FFF2-40B4-BE49-F238E27FC236}">
+                <a16:creationId xmlns:a16="http://schemas.microsoft.com/office/drawing/2014/main" id="{4CD2482F-678A-4467-8F59-6D1D17B6D7E5}"/>
+              </a:ext>
+            </a:extLst>
+          </p:cNvPr>
           <p:cNvSpPr>
             <a:spLocks noGrp="1"/>
           </p:cNvSpPr>
@@ -1697,9 +2169,9 @@
           </a:bodyPr>
           <a:lstStyle/>
           <a:p>
-            <a:fld id="{E6744CE3-0875-4B69-89C0-6F72D8139561}" type="datetimeFigureOut">
+            <a:fld id="{EA9C4514-AD86-4E80-B6BC-BD70E0C475B2}" type="datetimeFigureOut">
               <a:rPr lang="en-GB" smtClean="0"/>
-              <a:t>26/05/17</a:t>
+              <a:t>29/09/2026</a:t>
             </a:fld>
             <a:endParaRPr lang="en-GB"/>
           </a:p>
@@ -1707,7 +2179,13 @@
       </p:sp>
       <p:sp>
         <p:nvSpPr>
-          <p:cNvPr id="3" name="Footer Placeholder 2"/>
+          <p:cNvPr id="3" name="Footer Placeholder 2">
+            <a:extLst>
+              <a:ext uri="{FF2B5EF4-FFF2-40B4-BE49-F238E27FC236}">
+                <a16:creationId xmlns:a16="http://schemas.microsoft.com/office/drawing/2014/main" id="{7B176719-E9B6-42C4-98FA-C00C5D2C00A8}"/>
+              </a:ext>
+            </a:extLst>
+          </p:cNvPr>
           <p:cNvSpPr>
             <a:spLocks noGrp="1"/>
           </p:cNvSpPr>
@@ -1728,7 +2206,13 @@
       </p:sp>
       <p:sp>
         <p:nvSpPr>
-          <p:cNvPr id="4" name="Slide Number Placeholder 3"/>
+          <p:cNvPr id="4" name="Slide Number Placeholder 3">
+            <a:extLst>
+              <a:ext uri="{FF2B5EF4-FFF2-40B4-BE49-F238E27FC236}">
+                <a16:creationId xmlns:a16="http://schemas.microsoft.com/office/drawing/2014/main" id="{39FD3B97-834C-4418-858A-BC52283B44FF}"/>
+              </a:ext>
+            </a:extLst>
+          </p:cNvPr>
           <p:cNvSpPr>
             <a:spLocks noGrp="1"/>
           </p:cNvSpPr>
@@ -1743,7 +2227,7 @@
           </a:bodyPr>
           <a:lstStyle/>
           <a:p>
-            <a:fld id="{8DADB20D-508E-4C6D-A9E4-257D5607B0F6}" type="slidenum">
+            <a:fld id="{E3EE339C-4041-4A50-8D8F-1CA5E34F9F57}" type="slidenum">
               <a:rPr lang="en-GB" smtClean="0"/>
               <a:t>‹#›</a:t>
             </a:fld>
@@ -1754,7 +2238,7 @@
     </p:spTree>
     <p:extLst>
       <p:ext uri="{BB962C8B-B14F-4D97-AF65-F5344CB8AC3E}">
-        <p14:creationId xmlns:p14="http://schemas.microsoft.com/office/powerpoint/2010/main" val="2755996059"/>
+        <p14:creationId xmlns:p14="http://schemas.microsoft.com/office/powerpoint/2010/main" val="1969228709"/>
       </p:ext>
     </p:extLst>
   </p:cSld>
@@ -1765,7 +2249,7 @@
 </file>
 
 <file path=ppt/slideLayouts/slideLayout8.xml><?xml version="1.0" encoding="utf-8"?>
-<p:sldLayout xmlns:a="http://schemas.openxmlformats.org/drawingml/2006/main" xmlns:r="http://schemas.openxmlformats.org/officeDocument/2006/relationships" xmlns:p="http://schemas.openxmlformats.org/presentationml/2006/main" type="twoObj" preserve="1">
+<p:sldLayout xmlns:a="http://schemas.openxmlformats.org/drawingml/2006/main" xmlns:r="http://schemas.openxmlformats.org/officeDocument/2006/relationships" xmlns:p="http://schemas.openxmlformats.org/presentationml/2006/main" type="objTx" preserve="1">
   <p:cSld name="Content with Caption">
     <p:spTree>
       <p:nvGrpSpPr>
@@ -1783,110 +2267,131 @@
       </p:grpSpPr>
       <p:sp>
         <p:nvSpPr>
-          <p:cNvPr id="2" name="Title 1"/>
+          <p:cNvPr id="2" name="Title 1">
+            <a:extLst>
+              <a:ext uri="{FF2B5EF4-FFF2-40B4-BE49-F238E27FC236}">
+                <a16:creationId xmlns:a16="http://schemas.microsoft.com/office/drawing/2014/main" id="{9E90BC67-8730-4DAD-AAAD-C49F392065B9}"/>
+              </a:ext>
+            </a:extLst>
+          </p:cNvPr>
           <p:cNvSpPr>
             <a:spLocks noGrp="1"/>
           </p:cNvSpPr>
           <p:nvPr>
             <p:ph type="title"/>
-          </p:nvPr>
-        </p:nvSpPr>
-        <p:spPr/>
-        <p:txBody>
-          <a:bodyPr>
-            <a:normAutofit xmlns:a="http://schemas.openxmlformats.org/drawingml/2006/main"/>
-          </a:bodyPr>
-          <a:lstStyle/>
-          <a:p>
-            <a:r>
-              <a:rPr lang="en-US" smtClean="0"/>
-              <a:t>Click to edit Master title style</a:t>
-            </a:r>
-            <a:endParaRPr lang="en-GB"/>
-          </a:p>
-        </p:txBody>
-      </p:sp>
-      <p:sp>
-        <p:nvSpPr>
-          <p:cNvPr id="3" name="Content Placeholder 2"/>
-          <p:cNvSpPr>
-            <a:spLocks noGrp="1"/>
-          </p:cNvSpPr>
-          <p:nvPr>
-            <p:ph sz="half" idx="1"/>
           </p:nvPr>
         </p:nvSpPr>
         <p:spPr>
           <a:xfrm>
-            <a:off x="609600" y="1600200"/>
-            <a:ext cx="5384800" cy="4525963"/>
+            <a:off x="839788" y="457200"/>
+            <a:ext cx="3932237" cy="1600200"/>
           </a:xfrm>
         </p:spPr>
         <p:txBody>
-          <a:bodyPr>
+          <a:bodyPr anchor="b">
             <a:normAutofit xmlns:a="http://schemas.openxmlformats.org/drawingml/2006/main"/>
           </a:bodyPr>
           <a:lstStyle>
             <a:lvl1pPr>
-              <a:defRPr sz="2800"/>
+              <a:defRPr sz="3200"/>
+            </a:lvl1pPr>
+          </a:lstStyle>
+          <a:p>
+            <a:r>
+              <a:rPr lang="en-US"/>
+              <a:t>Click to edit Master title style</a:t>
+            </a:r>
+            <a:endParaRPr lang="en-GB"/>
+          </a:p>
+        </p:txBody>
+      </p:sp>
+      <p:sp>
+        <p:nvSpPr>
+          <p:cNvPr id="3" name="Content Placeholder 2">
+            <a:extLst>
+              <a:ext uri="{FF2B5EF4-FFF2-40B4-BE49-F238E27FC236}">
+                <a16:creationId xmlns:a16="http://schemas.microsoft.com/office/drawing/2014/main" id="{E768DB9A-B8B7-4197-BE77-2873D7CE6D9D}"/>
+              </a:ext>
+            </a:extLst>
+          </p:cNvPr>
+          <p:cNvSpPr>
+            <a:spLocks noGrp="1"/>
+          </p:cNvSpPr>
+          <p:nvPr>
+            <p:ph idx="1"/>
+          </p:nvPr>
+        </p:nvSpPr>
+        <p:spPr>
+          <a:xfrm>
+            <a:off x="5183188" y="987425"/>
+            <a:ext cx="6172200" cy="4873625"/>
+          </a:xfrm>
+        </p:spPr>
+        <p:txBody>
+          <a:bodyPr>
+            <a:normAutofit xmlns:a="http://schemas.openxmlformats.org/drawingml/2006/main"/>
+          </a:bodyPr>
+          <a:lstStyle>
+            <a:lvl1pPr>
+              <a:defRPr sz="3200"/>
             </a:lvl1pPr>
             <a:lvl2pPr>
-              <a:defRPr sz="2400"/>
+              <a:defRPr sz="2800"/>
             </a:lvl2pPr>
             <a:lvl3pPr>
-              <a:defRPr sz="2000"/>
+              <a:defRPr sz="2400"/>
             </a:lvl3pPr>
             <a:lvl4pPr>
-              <a:defRPr sz="1800"/>
+              <a:defRPr sz="2000"/>
             </a:lvl4pPr>
             <a:lvl5pPr>
-              <a:defRPr sz="1800"/>
+              <a:defRPr sz="2000"/>
             </a:lvl5pPr>
             <a:lvl6pPr>
-              <a:defRPr sz="1800"/>
+              <a:defRPr sz="2000"/>
             </a:lvl6pPr>
             <a:lvl7pPr>
-              <a:defRPr sz="1800"/>
+              <a:defRPr sz="2000"/>
             </a:lvl7pPr>
             <a:lvl8pPr>
-              <a:defRPr sz="1800"/>
+              <a:defRPr sz="2000"/>
             </a:lvl8pPr>
             <a:lvl9pPr>
-              <a:defRPr sz="1800"/>
+              <a:defRPr sz="2000"/>
             </a:lvl9pPr>
           </a:lstStyle>
           <a:p>
             <a:pPr lvl="0"/>
             <a:r>
-              <a:rPr lang="en-US" smtClean="0"/>
+              <a:rPr lang="en-US"/>
               <a:t>Click to edit Master text styles</a:t>
             </a:r>
           </a:p>
           <a:p>
             <a:pPr lvl="1"/>
             <a:r>
-              <a:rPr lang="en-US" smtClean="0"/>
+              <a:rPr lang="en-US"/>
               <a:t>Second level</a:t>
             </a:r>
           </a:p>
           <a:p>
             <a:pPr lvl="2"/>
             <a:r>
-              <a:rPr lang="en-US" smtClean="0"/>
+              <a:rPr lang="en-US"/>
               <a:t>Third level</a:t>
             </a:r>
           </a:p>
           <a:p>
             <a:pPr lvl="3"/>
             <a:r>
-              <a:rPr lang="en-US" smtClean="0"/>
+              <a:rPr lang="en-US"/>
               <a:t>Fourth level</a:t>
             </a:r>
           </a:p>
           <a:p>
             <a:pPr lvl="4"/>
             <a:r>
-              <a:rPr lang="en-US" smtClean="0"/>
+              <a:rPr lang="en-US"/>
               <a:t>Fifth level</a:t>
             </a:r>
             <a:endParaRPr lang="en-GB"/>
@@ -1895,18 +2400,24 @@
       </p:sp>
       <p:sp>
         <p:nvSpPr>
-          <p:cNvPr id="4" name="Content Placeholder 3"/>
-          <p:cNvSpPr>
-            <a:spLocks noGrp="1"/>
-          </p:cNvSpPr>
-          <p:nvPr>
-            <p:ph sz="half" idx="2"/>
+          <p:cNvPr id="4" name="Text Placeholder 3">
+            <a:extLst>
+              <a:ext uri="{FF2B5EF4-FFF2-40B4-BE49-F238E27FC236}">
+                <a16:creationId xmlns:a16="http://schemas.microsoft.com/office/drawing/2014/main" id="{EEE6F6BA-7672-45B6-AC5D-957AE2C741DB}"/>
+              </a:ext>
+            </a:extLst>
+          </p:cNvPr>
+          <p:cNvSpPr>
+            <a:spLocks noGrp="1"/>
+          </p:cNvSpPr>
+          <p:nvPr>
+            <p:ph type="body" sz="half" idx="2"/>
           </p:nvPr>
         </p:nvSpPr>
         <p:spPr>
           <a:xfrm>
-            <a:off x="6197600" y="1600200"/>
-            <a:ext cx="5384800" cy="4525963"/>
+            <a:off x="839788" y="2057400"/>
+            <a:ext cx="3932237" cy="3811588"/>
           </a:xfrm>
         </p:spPr>
         <p:txBody>
@@ -1914,75 +2425,61 @@
             <a:normAutofit xmlns:a="http://schemas.openxmlformats.org/drawingml/2006/main"/>
           </a:bodyPr>
           <a:lstStyle>
-            <a:lvl1pPr>
-              <a:defRPr sz="2800"/>
+            <a:lvl1pPr marL="0" indent="0">
+              <a:buNone/>
+              <a:defRPr sz="1600"/>
             </a:lvl1pPr>
-            <a:lvl2pPr>
-              <a:defRPr sz="2400"/>
+            <a:lvl2pPr marL="457200" indent="0">
+              <a:buNone/>
+              <a:defRPr sz="1400"/>
             </a:lvl2pPr>
-            <a:lvl3pPr>
-              <a:defRPr sz="2000"/>
+            <a:lvl3pPr marL="914400" indent="0">
+              <a:buNone/>
+              <a:defRPr sz="1200"/>
             </a:lvl3pPr>
-            <a:lvl4pPr>
-              <a:defRPr sz="1800"/>
+            <a:lvl4pPr marL="1371600" indent="0">
+              <a:buNone/>
+              <a:defRPr sz="1000"/>
             </a:lvl4pPr>
-            <a:lvl5pPr>
-              <a:defRPr sz="1800"/>
+            <a:lvl5pPr marL="1828800" indent="0">
+              <a:buNone/>
+              <a:defRPr sz="1000"/>
             </a:lvl5pPr>
-            <a:lvl6pPr>
-              <a:defRPr sz="1800"/>
+            <a:lvl6pPr marL="2286000" indent="0">
+              <a:buNone/>
+              <a:defRPr sz="1000"/>
             </a:lvl6pPr>
-            <a:lvl7pPr>
-              <a:defRPr sz="1800"/>
+            <a:lvl7pPr marL="2743200" indent="0">
+              <a:buNone/>
+              <a:defRPr sz="1000"/>
             </a:lvl7pPr>
-            <a:lvl8pPr>
-              <a:defRPr sz="1800"/>
+            <a:lvl8pPr marL="3200400" indent="0">
+              <a:buNone/>
+              <a:defRPr sz="1000"/>
             </a:lvl8pPr>
-            <a:lvl9pPr>
-              <a:defRPr sz="1800"/>
+            <a:lvl9pPr marL="3657600" indent="0">
+              <a:buNone/>
+              <a:defRPr sz="1000"/>
             </a:lvl9pPr>
           </a:lstStyle>
           <a:p>
             <a:pPr lvl="0"/>
             <a:r>
-              <a:rPr lang="en-US" smtClean="0"/>
+              <a:rPr lang="en-US"/>
               <a:t>Click to edit Master text styles</a:t>
             </a:r>
           </a:p>
-          <a:p>
-            <a:pPr lvl="1"/>
-            <a:r>
-              <a:rPr lang="en-US" smtClean="0"/>
-              <a:t>Second level</a:t>
-            </a:r>
-          </a:p>
-          <a:p>
-            <a:pPr lvl="2"/>
-            <a:r>
-              <a:rPr lang="en-US" smtClean="0"/>
-              <a:t>Third level</a:t>
-            </a:r>
-          </a:p>
-          <a:p>
-            <a:pPr lvl="3"/>
-            <a:r>
-              <a:rPr lang="en-US" smtClean="0"/>
-              <a:t>Fourth level</a:t>
-            </a:r>
-          </a:p>
-          <a:p>
-            <a:pPr lvl="4"/>
-            <a:r>
-              <a:rPr lang="en-US" smtClean="0"/>
-              <a:t>Fifth level</a:t>
-            </a:r>
-            <a:endParaRPr lang="en-GB"/>
-          </a:p>
-        </p:txBody>
-      </p:sp>
-      <p:sp>
-        <p:nvSpPr>
-          <p:cNvPr id="5" name="Date Placeholder 4"/>
+        </p:txBody>
+      </p:sp>
+      <p:sp>
+        <p:nvSpPr>
+          <p:cNvPr id="5" name="Date Placeholder 4">
+            <a:extLst>
+              <a:ext uri="{FF2B5EF4-FFF2-40B4-BE49-F238E27FC236}">
+                <a16:creationId xmlns:a16="http://schemas.microsoft.com/office/drawing/2014/main" id="{932B164E-EDD2-4F5E-9802-C5F89355B554}"/>
+              </a:ext>
+            </a:extLst>
+          </p:cNvPr>
           <p:cNvSpPr>
             <a:spLocks noGrp="1"/>
           </p:cNvSpPr>
@@ -1997,9 +2494,9 @@
           </a:bodyPr>
           <a:lstStyle/>
           <a:p>
-            <a:fld id="{E6744CE3-0875-4B69-89C0-6F72D8139561}" type="datetimeFigureOut">
+            <a:fld id="{EA9C4514-AD86-4E80-B6BC-BD70E0C475B2}" type="datetimeFigureOut">
               <a:rPr lang="en-GB" smtClean="0"/>
-              <a:t>26/05/17</a:t>
+              <a:t>29/09/2026</a:t>
             </a:fld>
             <a:endParaRPr lang="en-GB"/>
           </a:p>
@@ -2007,7 +2504,13 @@
       </p:sp>
       <p:sp>
         <p:nvSpPr>
-          <p:cNvPr id="6" name="Footer Placeholder 5"/>
+          <p:cNvPr id="6" name="Footer Placeholder 5">
+            <a:extLst>
+              <a:ext uri="{FF2B5EF4-FFF2-40B4-BE49-F238E27FC236}">
+                <a16:creationId xmlns:a16="http://schemas.microsoft.com/office/drawing/2014/main" id="{07132695-DC4B-4E95-AB94-91AA1B276179}"/>
+              </a:ext>
+            </a:extLst>
+          </p:cNvPr>
           <p:cNvSpPr>
             <a:spLocks noGrp="1"/>
           </p:cNvSpPr>
@@ -2028,7 +2531,13 @@
       </p:sp>
       <p:sp>
         <p:nvSpPr>
-          <p:cNvPr id="7" name="Slide Number Placeholder 6"/>
+          <p:cNvPr id="7" name="Slide Number Placeholder 6">
+            <a:extLst>
+              <a:ext uri="{FF2B5EF4-FFF2-40B4-BE49-F238E27FC236}">
+                <a16:creationId xmlns:a16="http://schemas.microsoft.com/office/drawing/2014/main" id="{E0B9D565-E266-4EFD-918A-3C68A8152EDF}"/>
+              </a:ext>
+            </a:extLst>
+          </p:cNvPr>
           <p:cNvSpPr>
             <a:spLocks noGrp="1"/>
           </p:cNvSpPr>
@@ -2043,7 +2552,7 @@
           </a:bodyPr>
           <a:lstStyle/>
           <a:p>
-            <a:fld id="{8DADB20D-508E-4C6D-A9E4-257D5607B0F6}" type="slidenum">
+            <a:fld id="{E3EE339C-4041-4A50-8D8F-1CA5E34F9F57}" type="slidenum">
               <a:rPr lang="en-GB" smtClean="0"/>
               <a:t>‹#›</a:t>
             </a:fld>
@@ -2054,7 +2563,312 @@
     </p:spTree>
     <p:extLst>
       <p:ext uri="{BB962C8B-B14F-4D97-AF65-F5344CB8AC3E}">
-        <p14:creationId xmlns:p14="http://schemas.microsoft.com/office/powerpoint/2010/main" val="468392282"/>
+        <p14:creationId xmlns:p14="http://schemas.microsoft.com/office/powerpoint/2010/main" val="605958189"/>
+      </p:ext>
+    </p:extLst>
+  </p:cSld>
+  <p:clrMapOvr>
+    <a:masterClrMapping/>
+  </p:clrMapOvr>
+</p:sldLayout>
+</file>
+
+<file path=ppt/slideLayouts/slideLayout9.xml><?xml version="1.0" encoding="utf-8"?>
+<p:sldLayout xmlns:a="http://schemas.openxmlformats.org/drawingml/2006/main" xmlns:r="http://schemas.openxmlformats.org/officeDocument/2006/relationships" xmlns:p="http://schemas.openxmlformats.org/presentationml/2006/main" type="picTx" preserve="1">
+  <p:cSld name="Picture with Caption">
+    <p:spTree>
+      <p:nvGrpSpPr>
+        <p:cNvPr id="1" name=""/>
+        <p:cNvGrpSpPr/>
+        <p:nvPr/>
+      </p:nvGrpSpPr>
+      <p:grpSpPr>
+        <a:xfrm>
+          <a:off x="0" y="0"/>
+          <a:ext cx="0" cy="0"/>
+          <a:chOff x="0" y="0"/>
+          <a:chExt cx="0" cy="0"/>
+        </a:xfrm>
+      </p:grpSpPr>
+      <p:sp>
+        <p:nvSpPr>
+          <p:cNvPr id="2" name="Title 1">
+            <a:extLst>
+              <a:ext uri="{FF2B5EF4-FFF2-40B4-BE49-F238E27FC236}">
+                <a16:creationId xmlns:a16="http://schemas.microsoft.com/office/drawing/2014/main" id="{BF08D85F-0A79-46CA-AFD5-A3E7E94F16DF}"/>
+              </a:ext>
+            </a:extLst>
+          </p:cNvPr>
+          <p:cNvSpPr>
+            <a:spLocks noGrp="1"/>
+          </p:cNvSpPr>
+          <p:nvPr>
+            <p:ph type="title"/>
+          </p:nvPr>
+        </p:nvSpPr>
+        <p:spPr>
+          <a:xfrm>
+            <a:off x="839788" y="457200"/>
+            <a:ext cx="3932237" cy="1600200"/>
+          </a:xfrm>
+        </p:spPr>
+        <p:txBody>
+          <a:bodyPr anchor="b">
+            <a:normAutofit xmlns:a="http://schemas.openxmlformats.org/drawingml/2006/main"/>
+          </a:bodyPr>
+          <a:lstStyle>
+            <a:lvl1pPr>
+              <a:defRPr sz="3200"/>
+            </a:lvl1pPr>
+          </a:lstStyle>
+          <a:p>
+            <a:r>
+              <a:rPr lang="en-US"/>
+              <a:t>Click to edit Master title style</a:t>
+            </a:r>
+            <a:endParaRPr lang="en-GB"/>
+          </a:p>
+        </p:txBody>
+      </p:sp>
+      <p:sp>
+        <p:nvSpPr>
+          <p:cNvPr id="3" name="Picture Placeholder 2">
+            <a:extLst>
+              <a:ext uri="{FF2B5EF4-FFF2-40B4-BE49-F238E27FC236}">
+                <a16:creationId xmlns:a16="http://schemas.microsoft.com/office/drawing/2014/main" id="{927B48EC-FEA6-49E7-AB5D-6261FE6425B8}"/>
+              </a:ext>
+            </a:extLst>
+          </p:cNvPr>
+          <p:cNvSpPr>
+            <a:spLocks noGrp="1"/>
+          </p:cNvSpPr>
+          <p:nvPr>
+            <p:ph type="pic" idx="1"/>
+          </p:nvPr>
+        </p:nvSpPr>
+        <p:spPr>
+          <a:xfrm>
+            <a:off x="5183188" y="987425"/>
+            <a:ext cx="6172200" cy="4873625"/>
+          </a:xfrm>
+        </p:spPr>
+        <p:txBody>
+          <a:bodyPr>
+            <a:normAutofit xmlns:a="http://schemas.openxmlformats.org/drawingml/2006/main"/>
+          </a:bodyPr>
+          <a:lstStyle>
+            <a:lvl1pPr marL="0" indent="0">
+              <a:buNone/>
+              <a:defRPr sz="3200"/>
+            </a:lvl1pPr>
+            <a:lvl2pPr marL="457200" indent="0">
+              <a:buNone/>
+              <a:defRPr sz="2800"/>
+            </a:lvl2pPr>
+            <a:lvl3pPr marL="914400" indent="0">
+              <a:buNone/>
+              <a:defRPr sz="2400"/>
+            </a:lvl3pPr>
+            <a:lvl4pPr marL="1371600" indent="0">
+              <a:buNone/>
+              <a:defRPr sz="2000"/>
+            </a:lvl4pPr>
+            <a:lvl5pPr marL="1828800" indent="0">
+              <a:buNone/>
+              <a:defRPr sz="2000"/>
+            </a:lvl5pPr>
+            <a:lvl6pPr marL="2286000" indent="0">
+              <a:buNone/>
+              <a:defRPr sz="2000"/>
+            </a:lvl6pPr>
+            <a:lvl7pPr marL="2743200" indent="0">
+              <a:buNone/>
+              <a:defRPr sz="2000"/>
+            </a:lvl7pPr>
+            <a:lvl8pPr marL="3200400" indent="0">
+              <a:buNone/>
+              <a:defRPr sz="2000"/>
+            </a:lvl8pPr>
+            <a:lvl9pPr marL="3657600" indent="0">
+              <a:buNone/>
+              <a:defRPr sz="2000"/>
+            </a:lvl9pPr>
+          </a:lstStyle>
+          <a:p>
+            <a:r>
+              <a:rPr lang="en-US"/>
+              <a:t>Click icon to add picture</a:t>
+            </a:r>
+            <a:endParaRPr lang="en-GB"/>
+          </a:p>
+        </p:txBody>
+      </p:sp>
+      <p:sp>
+        <p:nvSpPr>
+          <p:cNvPr id="4" name="Text Placeholder 3">
+            <a:extLst>
+              <a:ext uri="{FF2B5EF4-FFF2-40B4-BE49-F238E27FC236}">
+                <a16:creationId xmlns:a16="http://schemas.microsoft.com/office/drawing/2014/main" id="{49A1B63C-A31B-4BBB-87C9-79682F644D02}"/>
+              </a:ext>
+            </a:extLst>
+          </p:cNvPr>
+          <p:cNvSpPr>
+            <a:spLocks noGrp="1"/>
+          </p:cNvSpPr>
+          <p:nvPr>
+            <p:ph type="body" sz="half" idx="2"/>
+          </p:nvPr>
+        </p:nvSpPr>
+        <p:spPr>
+          <a:xfrm>
+            <a:off x="839788" y="2057400"/>
+            <a:ext cx="3932237" cy="3811588"/>
+          </a:xfrm>
+        </p:spPr>
+        <p:txBody>
+          <a:bodyPr>
+            <a:normAutofit xmlns:a="http://schemas.openxmlformats.org/drawingml/2006/main"/>
+          </a:bodyPr>
+          <a:lstStyle>
+            <a:lvl1pPr marL="0" indent="0">
+              <a:buNone/>
+              <a:defRPr sz="1600"/>
+            </a:lvl1pPr>
+            <a:lvl2pPr marL="457200" indent="0">
+              <a:buNone/>
+              <a:defRPr sz="1400"/>
+            </a:lvl2pPr>
+            <a:lvl3pPr marL="914400" indent="0">
+              <a:buNone/>
+              <a:defRPr sz="1200"/>
+            </a:lvl3pPr>
+            <a:lvl4pPr marL="1371600" indent="0">
+              <a:buNone/>
+              <a:defRPr sz="1000"/>
+            </a:lvl4pPr>
+            <a:lvl5pPr marL="1828800" indent="0">
+              <a:buNone/>
+              <a:defRPr sz="1000"/>
+            </a:lvl5pPr>
+            <a:lvl6pPr marL="2286000" indent="0">
+              <a:buNone/>
+              <a:defRPr sz="1000"/>
+            </a:lvl6pPr>
+            <a:lvl7pPr marL="2743200" indent="0">
+              <a:buNone/>
+              <a:defRPr sz="1000"/>
+            </a:lvl7pPr>
+            <a:lvl8pPr marL="3200400" indent="0">
+              <a:buNone/>
+              <a:defRPr sz="1000"/>
+            </a:lvl8pPr>
+            <a:lvl9pPr marL="3657600" indent="0">
+              <a:buNone/>
+              <a:defRPr sz="1000"/>
+            </a:lvl9pPr>
+          </a:lstStyle>
+          <a:p>
+            <a:pPr lvl="0"/>
+            <a:r>
+              <a:rPr lang="en-US"/>
+              <a:t>Click to edit Master text styles</a:t>
+            </a:r>
+          </a:p>
+        </p:txBody>
+      </p:sp>
+      <p:sp>
+        <p:nvSpPr>
+          <p:cNvPr id="5" name="Date Placeholder 4">
+            <a:extLst>
+              <a:ext uri="{FF2B5EF4-FFF2-40B4-BE49-F238E27FC236}">
+                <a16:creationId xmlns:a16="http://schemas.microsoft.com/office/drawing/2014/main" id="{0B0F8CED-32AD-4F32-BAE9-4F522C6161A5}"/>
+              </a:ext>
+            </a:extLst>
+          </p:cNvPr>
+          <p:cNvSpPr>
+            <a:spLocks noGrp="1"/>
+          </p:cNvSpPr>
+          <p:nvPr>
+            <p:ph type="dt" sz="half" idx="10"/>
+          </p:nvPr>
+        </p:nvSpPr>
+        <p:spPr/>
+        <p:txBody>
+          <a:bodyPr>
+            <a:normAutofit xmlns:a="http://schemas.openxmlformats.org/drawingml/2006/main"/>
+          </a:bodyPr>
+          <a:lstStyle/>
+          <a:p>
+            <a:fld id="{EA9C4514-AD86-4E80-B6BC-BD70E0C475B2}" type="datetimeFigureOut">
+              <a:rPr lang="en-GB" smtClean="0"/>
+              <a:t>29/09/2026</a:t>
+            </a:fld>
+            <a:endParaRPr lang="en-GB"/>
+          </a:p>
+        </p:txBody>
+      </p:sp>
+      <p:sp>
+        <p:nvSpPr>
+          <p:cNvPr id="6" name="Footer Placeholder 5">
+            <a:extLst>
+              <a:ext uri="{FF2B5EF4-FFF2-40B4-BE49-F238E27FC236}">
+                <a16:creationId xmlns:a16="http://schemas.microsoft.com/office/drawing/2014/main" id="{9F4D75CD-72B4-4271-ABE4-2E87AEBCD670}"/>
+              </a:ext>
+            </a:extLst>
+          </p:cNvPr>
+          <p:cNvSpPr>
+            <a:spLocks noGrp="1"/>
+          </p:cNvSpPr>
+          <p:nvPr>
+            <p:ph type="ftr" sz="quarter" idx="11"/>
+          </p:nvPr>
+        </p:nvSpPr>
+        <p:spPr/>
+        <p:txBody>
+          <a:bodyPr>
+            <a:normAutofit xmlns:a="http://schemas.openxmlformats.org/drawingml/2006/main"/>
+          </a:bodyPr>
+          <a:lstStyle/>
+          <a:p>
+            <a:endParaRPr lang="en-GB"/>
+          </a:p>
+        </p:txBody>
+      </p:sp>
+      <p:sp>
+        <p:nvSpPr>
+          <p:cNvPr id="7" name="Slide Number Placeholder 6">
+            <a:extLst>
+              <a:ext uri="{FF2B5EF4-FFF2-40B4-BE49-F238E27FC236}">
+                <a16:creationId xmlns:a16="http://schemas.microsoft.com/office/drawing/2014/main" id="{4D232CB6-AC02-4CAC-9C27-38730747A97D}"/>
+              </a:ext>
+            </a:extLst>
+          </p:cNvPr>
+          <p:cNvSpPr>
+            <a:spLocks noGrp="1"/>
+          </p:cNvSpPr>
+          <p:nvPr>
+            <p:ph type="sldNum" sz="quarter" idx="12"/>
+          </p:nvPr>
+        </p:nvSpPr>
+        <p:spPr/>
+        <p:txBody>
+          <a:bodyPr>
+            <a:normAutofit xmlns:a="http://schemas.openxmlformats.org/drawingml/2006/main"/>
+          </a:bodyPr>
+          <a:lstStyle/>
+          <a:p>
+            <a:fld id="{E3EE339C-4041-4A50-8D8F-1CA5E34F9F57}" type="slidenum">
+              <a:rPr lang="en-GB" smtClean="0"/>
+              <a:t>‹#›</a:t>
+            </a:fld>
+            <a:endParaRPr lang="en-GB"/>
+          </a:p>
+        </p:txBody>
+      </p:sp>
+    </p:spTree>
+    <p:extLst>
+      <p:ext uri="{BB962C8B-B14F-4D97-AF65-F5344CB8AC3E}">
+        <p14:creationId xmlns:p14="http://schemas.microsoft.com/office/powerpoint/2010/main" val="2722306126"/>
       </p:ext>
     </p:extLst>
   </p:cSld>
@@ -2088,7 +2902,13 @@
       </p:grpSpPr>
       <p:sp>
         <p:nvSpPr>
-          <p:cNvPr id="2" name="Title Placeholder 1"/>
+          <p:cNvPr id="2" name="Title Placeholder 1">
+            <a:extLst>
+              <a:ext uri="{FF2B5EF4-FFF2-40B4-BE49-F238E27FC236}">
+                <a16:creationId xmlns:a16="http://schemas.microsoft.com/office/drawing/2014/main" id="{8CB904A0-DB6C-4D8A-8930-4D0C33DB7D45}"/>
+              </a:ext>
+            </a:extLst>
+          </p:cNvPr>
           <p:cNvSpPr>
             <a:spLocks noGrp="1"/>
           </p:cNvSpPr>
@@ -2098,8 +2918,8 @@
         </p:nvSpPr>
         <p:spPr>
           <a:xfrm>
-            <a:off x="609600" y="274638"/>
-            <a:ext cx="10972800" cy="1143000"/>
+            <a:off x="838200" y="365125"/>
+            <a:ext cx="10515600" cy="1325563"/>
           </a:xfrm>
           <a:prstGeom prst="rect">
             <a:avLst/>
@@ -2112,16 +2932,22 @@
           <a:lstStyle/>
           <a:p>
             <a:r>
-              <a:rPr lang="en-US" smtClean="0"/>
+              <a:rPr lang="en-US"/>
               <a:t>Click to edit Master title style</a:t>
             </a:r>
-            <a:endParaRPr lang="en-GB"/>
-          </a:p>
-        </p:txBody>
-      </p:sp>
-      <p:sp>
-        <p:nvSpPr>
-          <p:cNvPr id="3" name="Text Placeholder 2"/>
+            <a:endParaRPr lang="en-GB" dirty="0"/>
+          </a:p>
+        </p:txBody>
+      </p:sp>
+      <p:sp>
+        <p:nvSpPr>
+          <p:cNvPr id="3" name="Text Placeholder 2">
+            <a:extLst>
+              <a:ext uri="{FF2B5EF4-FFF2-40B4-BE49-F238E27FC236}">
+                <a16:creationId xmlns:a16="http://schemas.microsoft.com/office/drawing/2014/main" id="{6CCC99F1-F115-4770-86C7-589E935A6A38}"/>
+              </a:ext>
+            </a:extLst>
+          </p:cNvPr>
           <p:cNvSpPr>
             <a:spLocks noGrp="1"/>
           </p:cNvSpPr>
@@ -2131,8 +2957,8 @@
         </p:nvSpPr>
         <p:spPr>
           <a:xfrm>
-            <a:off x="609600" y="1600200"/>
-            <a:ext cx="10972800" cy="4525963"/>
+            <a:off x="838200" y="1825625"/>
+            <a:ext cx="10515600" cy="4351338"/>
           </a:xfrm>
           <a:prstGeom prst="rect">
             <a:avLst/>
@@ -2146,35 +2972,35 @@
           <a:p>
             <a:pPr lvl="0"/>
             <a:r>
-              <a:rPr lang="en-US" smtClean="0"/>
+              <a:rPr lang="en-US"/>
               <a:t>Click to edit Master text styles</a:t>
             </a:r>
           </a:p>
           <a:p>
             <a:pPr lvl="1"/>
             <a:r>
-              <a:rPr lang="en-US" smtClean="0"/>
+              <a:rPr lang="en-US"/>
               <a:t>Second level</a:t>
             </a:r>
           </a:p>
           <a:p>
             <a:pPr lvl="2"/>
             <a:r>
-              <a:rPr lang="en-US" smtClean="0"/>
+              <a:rPr lang="en-US"/>
               <a:t>Third level</a:t>
             </a:r>
           </a:p>
           <a:p>
             <a:pPr lvl="3"/>
             <a:r>
-              <a:rPr lang="en-US" smtClean="0"/>
+              <a:rPr lang="en-US"/>
               <a:t>Fourth level</a:t>
             </a:r>
           </a:p>
           <a:p>
             <a:pPr lvl="4"/>
             <a:r>
-              <a:rPr lang="en-US" smtClean="0"/>
+              <a:rPr lang="en-US"/>
               <a:t>Fifth level</a:t>
             </a:r>
             <a:endParaRPr lang="en-GB"/>
@@ -2183,7 +3009,13 @@
       </p:sp>
       <p:sp>
         <p:nvSpPr>
-          <p:cNvPr id="4" name="Date Placeholder 3"/>
+          <p:cNvPr id="4" name="Date Placeholder 3">
+            <a:extLst>
+              <a:ext uri="{FF2B5EF4-FFF2-40B4-BE49-F238E27FC236}">
+                <a16:creationId xmlns:a16="http://schemas.microsoft.com/office/drawing/2014/main" id="{B89000B8-13D9-4C04-A168-8A6B6BF58DBA}"/>
+              </a:ext>
+            </a:extLst>
+          </p:cNvPr>
           <p:cNvSpPr>
             <a:spLocks noGrp="1"/>
           </p:cNvSpPr>
@@ -2193,8 +3025,8 @@
         </p:nvSpPr>
         <p:spPr>
           <a:xfrm>
-            <a:off x="609600" y="6356350"/>
-            <a:ext cx="2844800" cy="365125"/>
+            <a:off x="838200" y="6356350"/>
+            <a:ext cx="2743200" cy="365125"/>
           </a:xfrm>
           <a:prstGeom prst="rect">
             <a:avLst/>
@@ -2212,13 +3044,16 @@
                     <a:tint val="75000"/>
                   </a:schemeClr>
                 </a:solidFill>
+                <a:latin typeface="Segoe UI" panose="020B0502040204020203" pitchFamily="34" charset="0"/>
+                <a:cs typeface="Segoe UI" panose="020B0502040204020203" pitchFamily="34" charset="0"/>
               </a:defRPr>
             </a:lvl1pPr>
           </a:lstStyle>
           <a:p>
-            <a:fld id="{E6744CE3-0875-4B69-89C0-6F72D8139561}" type="datetimeFigureOut">
+            <a:fld id="{EA9C4514-AD86-4E80-B6BC-BD70E0C475B2}" type="datetimeFigureOut">
               <a:rPr lang="en-GB" smtClean="0"/>
-              <a:t>26/05/17</a:t>
+              <a:pPr/>
+              <a:t>29/09/2026</a:t>
             </a:fld>
             <a:endParaRPr lang="en-GB"/>
           </a:p>
@@ -2226,7 +3061,13 @@
       </p:sp>
       <p:sp>
         <p:nvSpPr>
-          <p:cNvPr id="5" name="Footer Placeholder 4"/>
+          <p:cNvPr id="5" name="Footer Placeholder 4">
+            <a:extLst>
+              <a:ext uri="{FF2B5EF4-FFF2-40B4-BE49-F238E27FC236}">
+                <a16:creationId xmlns:a16="http://schemas.microsoft.com/office/drawing/2014/main" id="{69DE90ED-AA7A-416C-9CD7-23B2DC80334A}"/>
+              </a:ext>
+            </a:extLst>
+          </p:cNvPr>
           <p:cNvSpPr>
             <a:spLocks noGrp="1"/>
           </p:cNvSpPr>
@@ -2236,8 +3077,8 @@
         </p:nvSpPr>
         <p:spPr>
           <a:xfrm>
-            <a:off x="4165600" y="6356350"/>
-            <a:ext cx="3860800" cy="365125"/>
+            <a:off x="4038600" y="6356350"/>
+            <a:ext cx="4114800" cy="365125"/>
           </a:xfrm>
           <a:prstGeom prst="rect">
             <a:avLst/>
@@ -2255,6 +3096,8 @@
                     <a:tint val="75000"/>
                   </a:schemeClr>
                 </a:solidFill>
+                <a:latin typeface="Segoe UI" panose="020B0502040204020203" pitchFamily="34" charset="0"/>
+                <a:cs typeface="Segoe UI" panose="020B0502040204020203" pitchFamily="34" charset="0"/>
               </a:defRPr>
             </a:lvl1pPr>
           </a:lstStyle>
@@ -2265,7 +3108,13 @@
       </p:sp>
       <p:sp>
         <p:nvSpPr>
-          <p:cNvPr id="6" name="Slide Number Placeholder 5"/>
+          <p:cNvPr id="6" name="Slide Number Placeholder 5">
+            <a:extLst>
+              <a:ext uri="{FF2B5EF4-FFF2-40B4-BE49-F238E27FC236}">
+                <a16:creationId xmlns:a16="http://schemas.microsoft.com/office/drawing/2014/main" id="{20AB00F5-91BA-4C61-8ED9-8105C869262D}"/>
+              </a:ext>
+            </a:extLst>
+          </p:cNvPr>
           <p:cNvSpPr>
             <a:spLocks noGrp="1"/>
           </p:cNvSpPr>
@@ -2275,8 +3124,8 @@
         </p:nvSpPr>
         <p:spPr>
           <a:xfrm>
-            <a:off x="8737600" y="6356350"/>
-            <a:ext cx="2844800" cy="365125"/>
+            <a:off x="8610600" y="6356350"/>
+            <a:ext cx="2743200" cy="365125"/>
           </a:xfrm>
           <a:prstGeom prst="rect">
             <a:avLst/>
@@ -2294,12 +3143,15 @@
                     <a:tint val="75000"/>
                   </a:schemeClr>
                 </a:solidFill>
+                <a:latin typeface="Segoe UI" panose="020B0502040204020203" pitchFamily="34" charset="0"/>
+                <a:cs typeface="Segoe UI" panose="020B0502040204020203" pitchFamily="34" charset="0"/>
               </a:defRPr>
             </a:lvl1pPr>
           </a:lstStyle>
           <a:p>
-            <a:fld id="{8DADB20D-508E-4C6D-A9E4-257D5607B0F6}" type="slidenum">
+            <a:fld id="{E3EE339C-4041-4A50-8D8F-1CA5E34F9F57}" type="slidenum">
               <a:rPr lang="en-GB" smtClean="0"/>
+              <a:pPr/>
               <a:t>‹#›</a:t>
             </a:fld>
             <a:endParaRPr lang="en-GB"/>
@@ -2309,7 +3161,7 @@
     </p:spTree>
     <p:extLst>
       <p:ext uri="{BB962C8B-B14F-4D97-AF65-F5344CB8AC3E}">
-        <p14:creationId xmlns:p14="http://schemas.microsoft.com/office/powerpoint/2010/main" val="307823620"/>
+        <p14:creationId xmlns:p14="http://schemas.microsoft.com/office/powerpoint/2010/main" val="382886165"/>
       </p:ext>
     </p:extLst>
   </p:cSld>
@@ -2322,11 +3174,17 @@
     <p:sldLayoutId id="2147483653" r:id="rId5"/>
     <p:sldLayoutId id="2147483654" r:id="rId6"/>
     <p:sldLayoutId id="2147483655" r:id="rId7"/>
-    <p:sldLayoutId xmlns:p="http://schemas.openxmlformats.org/presentationml/2006/main" xmlns:r="http://schemas.openxmlformats.org/officeDocument/2006/relationships" id="2147483656" r:id="rId9"/>
+    <p:sldLayoutId id="2147483656" r:id="rId8"/>
+    <p:sldLayoutId id="2147483657" r:id="rId9"/>
+    <p:sldLayoutId id="2147483658" r:id="rId10"/>
+    <p:sldLayoutId id="2147483659" r:id="rId11"/>
   </p:sldLayoutIdLst>
   <p:txStyles>
     <p:titleStyle>
       <a:lvl1pPr algn="l" defTabSz="914400" rtl="0" eaLnBrk="1" latinLnBrk="0" hangingPunct="1">
+        <a:lnSpc>
+          <a:spcPct val="90000"/>
+        </a:lnSpc>
         <a:spcBef>
           <a:spcPct val="0"/>
         </a:spcBef>
@@ -2335,16 +3193,19 @@
           <a:solidFill xmlns:a="http://schemas.openxmlformats.org/drawingml/2006/main">
             <a:srgbClr val="12314E"/>
           </a:solidFill>
-          <a:latin typeface="+mj-lt"/>
+          <a:latin typeface="Segoe UI" panose="020B0502040204020203" pitchFamily="34" charset="0"/>
           <a:ea typeface="+mj-ea"/>
-          <a:cs typeface="+mj-cs"/>
+          <a:cs typeface="Segoe UI" panose="020B0502040204020203" pitchFamily="34" charset="0"/>
         </a:defRPr>
       </a:lvl1pPr>
     </p:titleStyle>
     <p:bodyStyle>
-      <a:lvl1pPr marL="342900" indent="-342900" algn="l" defTabSz="914400" rtl="0" eaLnBrk="1" latinLnBrk="0" hangingPunct="1">
+      <a:lvl1pPr marL="228600" indent="-228600" algn="l" defTabSz="914400" rtl="0" eaLnBrk="1" latinLnBrk="0" hangingPunct="1">
+        <a:lnSpc>
+          <a:spcPct val="90000"/>
+        </a:lnSpc>
         <a:spcBef>
-          <a:spcPct val="20000"/>
+          <a:spcPts val="1000"/>
         </a:spcBef>
         <a:buFont typeface="Arial" panose="020B0604020202020204" pitchFamily="34" charset="0"/>
         <a:buChar char="•"/>
@@ -2352,29 +3213,17 @@
           <a:solidFill>
             <a:schemeClr val="tx1"/>
           </a:solidFill>
-          <a:latin typeface="+mn-lt"/>
+          <a:latin typeface="Segoe UI" panose="020B0502040204020203" pitchFamily="34" charset="0"/>
           <a:ea typeface="+mn-ea"/>
-          <a:cs typeface="+mn-cs"/>
+          <a:cs typeface="Segoe UI" panose="020B0502040204020203" pitchFamily="34" charset="0"/>
         </a:defRPr>
       </a:lvl1pPr>
-      <a:lvl2pPr marL="742950" indent="-285750" algn="l" defTabSz="914400" rtl="0" eaLnBrk="1" latinLnBrk="0" hangingPunct="1">
+      <a:lvl2pPr marL="685800" indent="-228600" algn="l" defTabSz="914400" rtl="0" eaLnBrk="1" latinLnBrk="0" hangingPunct="1">
+        <a:lnSpc>
+          <a:spcPct val="90000"/>
+        </a:lnSpc>
         <a:spcBef>
-          <a:spcPct val="20000"/>
-        </a:spcBef>
-        <a:buFont typeface="Arial" panose="020B0604020202020204" pitchFamily="34" charset="0"/>
-        <a:buChar char="–"/>
-        <a:defRPr sz="2800" kern="1200">
-          <a:solidFill>
-            <a:schemeClr val="tx1"/>
-          </a:solidFill>
-          <a:latin typeface="+mn-lt"/>
-          <a:ea typeface="+mn-ea"/>
-          <a:cs typeface="+mn-cs"/>
-        </a:defRPr>
-      </a:lvl2pPr>
-      <a:lvl3pPr marL="1143000" indent="-228600" algn="l" defTabSz="914400" rtl="0" eaLnBrk="1" latinLnBrk="0" hangingPunct="1">
-        <a:spcBef>
-          <a:spcPct val="20000"/>
+          <a:spcPts val="500"/>
         </a:spcBef>
         <a:buFont typeface="Arial" panose="020B0604020202020204" pitchFamily="34" charset="0"/>
         <a:buChar char="•"/>
@@ -2382,48 +3231,75 @@
           <a:solidFill>
             <a:schemeClr val="tx1"/>
           </a:solidFill>
-          <a:latin typeface="+mn-lt"/>
+          <a:latin typeface="Segoe UI" panose="020B0502040204020203" pitchFamily="34" charset="0"/>
           <a:ea typeface="+mn-ea"/>
-          <a:cs typeface="+mn-cs"/>
+          <a:cs typeface="Segoe UI" panose="020B0502040204020203" pitchFamily="34" charset="0"/>
         </a:defRPr>
-      </a:lvl3pPr>
-      <a:lvl4pPr marL="1600200" indent="-228600" algn="l" defTabSz="914400" rtl="0" eaLnBrk="1" latinLnBrk="0" hangingPunct="1">
+      </a:lvl2pPr>
+      <a:lvl3pPr marL="1143000" indent="-228600" algn="l" defTabSz="914400" rtl="0" eaLnBrk="1" latinLnBrk="0" hangingPunct="1">
+        <a:lnSpc>
+          <a:spcPct val="90000"/>
+        </a:lnSpc>
         <a:spcBef>
-          <a:spcPct val="20000"/>
+          <a:spcPts val="500"/>
         </a:spcBef>
         <a:buFont typeface="Arial" panose="020B0604020202020204" pitchFamily="34" charset="0"/>
-        <a:buChar char="–"/>
+        <a:buChar char="•"/>
         <a:defRPr sz="2000" kern="1200">
           <a:solidFill>
             <a:schemeClr val="tx1"/>
           </a:solidFill>
-          <a:latin typeface="+mn-lt"/>
+          <a:latin typeface="Segoe UI" panose="020B0502040204020203" pitchFamily="34" charset="0"/>
           <a:ea typeface="+mn-ea"/>
-          <a:cs typeface="+mn-cs"/>
+          <a:cs typeface="Segoe UI" panose="020B0502040204020203" pitchFamily="34" charset="0"/>
+        </a:defRPr>
+      </a:lvl3pPr>
+      <a:lvl4pPr marL="1600200" indent="-228600" algn="l" defTabSz="914400" rtl="0" eaLnBrk="1" latinLnBrk="0" hangingPunct="1">
+        <a:lnSpc>
+          <a:spcPct val="90000"/>
+        </a:lnSpc>
+        <a:spcBef>
+          <a:spcPts val="500"/>
+        </a:spcBef>
+        <a:buFont typeface="Arial" panose="020B0604020202020204" pitchFamily="34" charset="0"/>
+        <a:buChar char="•"/>
+        <a:defRPr sz="1800" kern="1200">
+          <a:solidFill>
+            <a:schemeClr val="tx1"/>
+          </a:solidFill>
+          <a:latin typeface="Segoe UI" panose="020B0502040204020203" pitchFamily="34" charset="0"/>
+          <a:ea typeface="+mn-ea"/>
+          <a:cs typeface="Segoe UI" panose="020B0502040204020203" pitchFamily="34" charset="0"/>
         </a:defRPr>
       </a:lvl4pPr>
       <a:lvl5pPr marL="2057400" indent="-228600" algn="l" defTabSz="914400" rtl="0" eaLnBrk="1" latinLnBrk="0" hangingPunct="1">
+        <a:lnSpc>
+          <a:spcPct val="90000"/>
+        </a:lnSpc>
         <a:spcBef>
-          <a:spcPct val="20000"/>
+          <a:spcPts val="500"/>
         </a:spcBef>
         <a:buFont typeface="Arial" panose="020B0604020202020204" pitchFamily="34" charset="0"/>
-        <a:buChar char="»"/>
-        <a:defRPr sz="2000" kern="1200">
+        <a:buChar char="•"/>
+        <a:defRPr sz="1800" kern="1200">
           <a:solidFill>
             <a:schemeClr val="tx1"/>
           </a:solidFill>
-          <a:latin typeface="+mn-lt"/>
+          <a:latin typeface="Segoe UI" panose="020B0502040204020203" pitchFamily="34" charset="0"/>
           <a:ea typeface="+mn-ea"/>
-          <a:cs typeface="+mn-cs"/>
+          <a:cs typeface="Segoe UI" panose="020B0502040204020203" pitchFamily="34" charset="0"/>
         </a:defRPr>
       </a:lvl5pPr>
       <a:lvl6pPr marL="2514600" indent="-228600" algn="l" defTabSz="914400" rtl="0" eaLnBrk="1" latinLnBrk="0" hangingPunct="1">
+        <a:lnSpc>
+          <a:spcPct val="90000"/>
+        </a:lnSpc>
         <a:spcBef>
-          <a:spcPct val="20000"/>
+          <a:spcPts val="500"/>
         </a:spcBef>
         <a:buFont typeface="Arial" panose="020B0604020202020204" pitchFamily="34" charset="0"/>
         <a:buChar char="•"/>
-        <a:defRPr sz="2000" kern="1200">
+        <a:defRPr sz="1800" kern="1200">
           <a:solidFill>
             <a:schemeClr val="tx1"/>
           </a:solidFill>
@@ -2433,12 +3309,15 @@
         </a:defRPr>
       </a:lvl6pPr>
       <a:lvl7pPr marL="2971800" indent="-228600" algn="l" defTabSz="914400" rtl="0" eaLnBrk="1" latinLnBrk="0" hangingPunct="1">
+        <a:lnSpc>
+          <a:spcPct val="90000"/>
+        </a:lnSpc>
         <a:spcBef>
-          <a:spcPct val="20000"/>
+          <a:spcPts val="500"/>
         </a:spcBef>
         <a:buFont typeface="Arial" panose="020B0604020202020204" pitchFamily="34" charset="0"/>
         <a:buChar char="•"/>
-        <a:defRPr sz="2000" kern="1200">
+        <a:defRPr sz="1800" kern="1200">
           <a:solidFill>
             <a:schemeClr val="tx1"/>
           </a:solidFill>
@@ -2448,12 +3327,15 @@
         </a:defRPr>
       </a:lvl7pPr>
       <a:lvl8pPr marL="3429000" indent="-228600" algn="l" defTabSz="914400" rtl="0" eaLnBrk="1" latinLnBrk="0" hangingPunct="1">
+        <a:lnSpc>
+          <a:spcPct val="90000"/>
+        </a:lnSpc>
         <a:spcBef>
-          <a:spcPct val="20000"/>
+          <a:spcPts val="500"/>
         </a:spcBef>
         <a:buFont typeface="Arial" panose="020B0604020202020204" pitchFamily="34" charset="0"/>
         <a:buChar char="•"/>
-        <a:defRPr sz="2000" kern="1200">
+        <a:defRPr sz="1800" kern="1200">
           <a:solidFill>
             <a:schemeClr val="tx1"/>
           </a:solidFill>
@@ -2463,12 +3345,15 @@
         </a:defRPr>
       </a:lvl8pPr>
       <a:lvl9pPr marL="3886200" indent="-228600" algn="l" defTabSz="914400" rtl="0" eaLnBrk="1" latinLnBrk="0" hangingPunct="1">
+        <a:lnSpc>
+          <a:spcPct val="90000"/>
+        </a:lnSpc>
         <a:spcBef>
-          <a:spcPct val="20000"/>
+          <a:spcPts val="500"/>
         </a:spcBef>
         <a:buFont typeface="Arial" panose="020B0604020202020204" pitchFamily="34" charset="0"/>
         <a:buChar char="•"/>
-        <a:defRPr sz="2000" kern="1200">
+        <a:defRPr sz="1800" kern="1200">
           <a:solidFill>
             <a:schemeClr val="tx1"/>
           </a:solidFill>
@@ -2574,13 +3459,53 @@
       </a:lvl9pPr>
     </p:otherStyle>
   </p:txStyles>
+  <p:extLst>
+    <p:ext uri="{27BBF7A9-308A-43DC-89C8-2F10F3537804}">
+      <p15:sldGuideLst xmlns:p15="http://schemas.microsoft.com/office/powerpoint/2012/main">
+        <p15:guide id="1" pos="3840" userDrawn="1">
+          <p15:clr>
+            <a:srgbClr val="547EBF"/>
+          </p15:clr>
+        </p15:guide>
+        <p15:guide id="2" orient="horz" pos="2160" userDrawn="1">
+          <p15:clr>
+            <a:srgbClr val="547EBF"/>
+          </p15:clr>
+        </p15:guide>
+        <p15:guide id="3" pos="7469" userDrawn="1">
+          <p15:clr>
+            <a:srgbClr val="547EBF"/>
+          </p15:clr>
+        </p15:guide>
+        <p15:guide id="4" pos="211" userDrawn="1">
+          <p15:clr>
+            <a:srgbClr val="547EBF"/>
+          </p15:clr>
+        </p15:guide>
+        <p15:guide id="5" orient="horz" pos="232" userDrawn="1">
+          <p15:clr>
+            <a:srgbClr val="547EBF"/>
+          </p15:clr>
+        </p15:guide>
+        <p15:guide id="6" orient="horz" pos="4088" userDrawn="1">
+          <p15:clr>
+            <a:srgbClr val="547EBF"/>
+          </p15:clr>
+        </p15:guide>
+        <p15:guide id="7" pos="2026" userDrawn="1">
+          <p15:clr>
+            <a:srgbClr val="547EBF"/>
+          </p15:clr>
+        </p15:guide>
+        <p15:guide id="8" pos="5654" userDrawn="1">
+          <p15:clr>
+            <a:srgbClr val="547EBF"/>
+          </p15:clr>
+        </p15:guide>
+      </p15:sldGuideLst>
+    </p:ext>
+  </p:extLst>
 </p:sldMaster>
-</file>
-
-<file path=ppt/tags/tag1.xml><?xml version="1.0" encoding="utf-8"?>
-<p:tagLst xmlns:a="http://schemas.openxmlformats.org/drawingml/2006/main" xmlns:r="http://schemas.openxmlformats.org/officeDocument/2006/relationships" xmlns:p="http://schemas.openxmlformats.org/presentationml/2006/main">
-  <p:tag name="_AMO_UNIQUEIDENTIFIER" val="Empty"/>
-</p:tagLst>
 </file>
 
 <file path=ppt/theme/theme1.xml><?xml version="1.0" encoding="utf-8"?>
@@ -2618,82 +3543,22 @@
         <a:srgbClr val="D8B04A"/>
       </a:accent6>
       <a:hlink>
-        <a:srgbClr val="0000FF"/>
+        <a:srgbClr val="0563C1"/>
       </a:hlink>
       <a:folHlink>
-        <a:srgbClr val="800080"/>
+        <a:srgbClr val="954F72"/>
       </a:folHlink>
     </a:clrScheme>
-    <a:fontScheme name="Office">
+    <a:fontScheme name="Segoe UI">
       <a:majorFont>
-        <a:latin typeface="Calibri"/>
+        <a:latin typeface="Segoe UI"/>
         <a:ea typeface=""/>
         <a:cs typeface=""/>
-        <a:font script="Jpan" typeface="ＭＳ Ｐゴシック"/>
-        <a:font script="Hang" typeface="맑은 고딕"/>
-        <a:font script="Hans" typeface="宋体"/>
-        <a:font script="Hant" typeface="新細明體"/>
-        <a:font script="Arab" typeface="Times New Roman"/>
-        <a:font script="Hebr" typeface="Times New Roman"/>
-        <a:font script="Thai" typeface="Angsana New"/>
-        <a:font script="Ethi" typeface="Nyala"/>
-        <a:font script="Beng" typeface="Vrinda"/>
-        <a:font script="Gujr" typeface="Shruti"/>
-        <a:font script="Khmr" typeface="MoolBoran"/>
-        <a:font script="Knda" typeface="Tunga"/>
-        <a:font script="Guru" typeface="Raavi"/>
-        <a:font script="Cans" typeface="Euphemia"/>
-        <a:font script="Cher" typeface="Plantagenet Cherokee"/>
-        <a:font script="Yiii" typeface="Microsoft Yi Baiti"/>
-        <a:font script="Tibt" typeface="Microsoft Himalaya"/>
-        <a:font script="Thaa" typeface="MV Boli"/>
-        <a:font script="Deva" typeface="Mangal"/>
-        <a:font script="Telu" typeface="Gautami"/>
-        <a:font script="Taml" typeface="Latha"/>
-        <a:font script="Syrc" typeface="Estrangelo Edessa"/>
-        <a:font script="Orya" typeface="Kalinga"/>
-        <a:font script="Mlym" typeface="Kartika"/>
-        <a:font script="Laoo" typeface="DokChampa"/>
-        <a:font script="Sinh" typeface="Iskoola Pota"/>
-        <a:font script="Mong" typeface="Mongolian Baiti"/>
-        <a:font script="Viet" typeface="Times New Roman"/>
-        <a:font script="Uigh" typeface="Microsoft Uighur"/>
-        <a:font script="Geor" typeface="Sylfaen"/>
       </a:majorFont>
       <a:minorFont>
-        <a:latin typeface="Calibri"/>
+        <a:latin typeface="Segoe UI"/>
         <a:ea typeface=""/>
         <a:cs typeface=""/>
-        <a:font script="Jpan" typeface="ＭＳ Ｐゴシック"/>
-        <a:font script="Hang" typeface="맑은 고딕"/>
-        <a:font script="Hans" typeface="宋体"/>
-        <a:font script="Hant" typeface="新細明體"/>
-        <a:font script="Arab" typeface="Arial"/>
-        <a:font script="Hebr" typeface="Arial"/>
-        <a:font script="Thai" typeface="Cordia New"/>
-        <a:font script="Ethi" typeface="Nyala"/>
-        <a:font script="Beng" typeface="Vrinda"/>
-        <a:font script="Gujr" typeface="Shruti"/>
-        <a:font script="Khmr" typeface="DaunPenh"/>
-        <a:font script="Knda" typeface="Tunga"/>
-        <a:font script="Guru" typeface="Raavi"/>
-        <a:font script="Cans" typeface="Euphemia"/>
-        <a:font script="Cher" typeface="Plantagenet Cherokee"/>
-        <a:font script="Yiii" typeface="Microsoft Yi Baiti"/>
-        <a:font script="Tibt" typeface="Microsoft Himalaya"/>
-        <a:font script="Thaa" typeface="MV Boli"/>
-        <a:font script="Deva" typeface="Mangal"/>
-        <a:font script="Telu" typeface="Gautami"/>
-        <a:font script="Taml" typeface="Latha"/>
-        <a:font script="Syrc" typeface="Estrangelo Edessa"/>
-        <a:font script="Orya" typeface="Kalinga"/>
-        <a:font script="Mlym" typeface="Kartika"/>
-        <a:font script="Laoo" typeface="DokChampa"/>
-        <a:font script="Sinh" typeface="Iskoola Pota"/>
-        <a:font script="Mong" typeface="Mongolian Baiti"/>
-        <a:font script="Viet" typeface="Arial"/>
-        <a:font script="Uigh" typeface="Microsoft Uighur"/>
-        <a:font script="Geor" typeface="Sylfaen"/>
       </a:minorFont>
     </a:fontScheme>
     <a:fmtScheme name="Office">
@@ -2705,165 +3570,141 @@
           <a:gsLst>
             <a:gs pos="0">
               <a:schemeClr val="phClr">
-                <a:tint val="50000"/>
-                <a:satMod val="300000"/>
+                <a:lumMod val="110000"/>
+                <a:satMod val="105000"/>
+                <a:tint val="67000"/>
               </a:schemeClr>
             </a:gs>
-            <a:gs pos="35000">
+            <a:gs pos="50000">
               <a:schemeClr val="phClr">
-                <a:tint val="37000"/>
-                <a:satMod val="300000"/>
+                <a:lumMod val="105000"/>
+                <a:satMod val="103000"/>
+                <a:tint val="73000"/>
               </a:schemeClr>
             </a:gs>
             <a:gs pos="100000">
               <a:schemeClr val="phClr">
-                <a:tint val="15000"/>
-                <a:satMod val="350000"/>
+                <a:lumMod val="105000"/>
+                <a:satMod val="109000"/>
+                <a:tint val="81000"/>
               </a:schemeClr>
             </a:gs>
           </a:gsLst>
-          <a:lin ang="16200000" scaled="1"/>
+          <a:lin ang="5400000" scaled="0"/>
         </a:gradFill>
         <a:gradFill rotWithShape="1">
           <a:gsLst>
             <a:gs pos="0">
               <a:schemeClr val="phClr">
-                <a:shade val="51000"/>
-                <a:satMod val="130000"/>
+                <a:satMod val="103000"/>
+                <a:lumMod val="102000"/>
+                <a:tint val="94000"/>
               </a:schemeClr>
             </a:gs>
-            <a:gs pos="80000">
+            <a:gs pos="50000">
               <a:schemeClr val="phClr">
-                <a:shade val="93000"/>
-                <a:satMod val="130000"/>
+                <a:satMod val="110000"/>
+                <a:lumMod val="100000"/>
+                <a:shade val="100000"/>
               </a:schemeClr>
             </a:gs>
             <a:gs pos="100000">
               <a:schemeClr val="phClr">
-                <a:shade val="94000"/>
-                <a:satMod val="135000"/>
+                <a:lumMod val="99000"/>
+                <a:satMod val="120000"/>
+                <a:shade val="78000"/>
               </a:schemeClr>
             </a:gs>
           </a:gsLst>
-          <a:lin ang="16200000" scaled="0"/>
+          <a:lin ang="5400000" scaled="0"/>
         </a:gradFill>
       </a:fillStyleLst>
       <a:lnStyleLst>
-        <a:ln w="9525" cap="flat" cmpd="sng" algn="ctr">
-          <a:solidFill>
-            <a:schemeClr val="phClr">
-              <a:shade val="95000"/>
-              <a:satMod val="105000"/>
-            </a:schemeClr>
-          </a:solidFill>
-          <a:prstDash val="solid"/>
-        </a:ln>
-        <a:ln w="25400" cap="flat" cmpd="sng" algn="ctr">
+        <a:ln w="6350" cap="flat" cmpd="sng" algn="ctr">
           <a:solidFill>
             <a:schemeClr val="phClr"/>
           </a:solidFill>
           <a:prstDash val="solid"/>
+          <a:miter lim="800000"/>
         </a:ln>
-        <a:ln w="38100" cap="flat" cmpd="sng" algn="ctr">
+        <a:ln w="12700" cap="flat" cmpd="sng" algn="ctr">
           <a:solidFill>
             <a:schemeClr val="phClr"/>
           </a:solidFill>
           <a:prstDash val="solid"/>
+          <a:miter lim="800000"/>
+        </a:ln>
+        <a:ln w="19050" cap="flat" cmpd="sng" algn="ctr">
+          <a:solidFill>
+            <a:schemeClr val="phClr"/>
+          </a:solidFill>
+          <a:prstDash val="solid"/>
+          <a:miter lim="800000"/>
         </a:ln>
       </a:lnStyleLst>
       <a:effectStyleLst>
         <a:effectStyle>
+          <a:effectLst/>
+        </a:effectStyle>
+        <a:effectStyle>
+          <a:effectLst/>
+        </a:effectStyle>
+        <a:effectStyle>
           <a:effectLst>
-            <a:outerShdw blurRad="40000" dist="20000" dir="5400000" rotWithShape="0">
+            <a:outerShdw blurRad="57150" dist="19050" dir="5400000" algn="ctr" rotWithShape="0">
               <a:srgbClr val="000000">
-                <a:alpha val="38000"/>
+                <a:alpha val="63000"/>
               </a:srgbClr>
             </a:outerShdw>
           </a:effectLst>
-        </a:effectStyle>
-        <a:effectStyle>
-          <a:effectLst>
-            <a:outerShdw blurRad="40000" dist="23000" dir="5400000" rotWithShape="0">
-              <a:srgbClr val="000000">
-                <a:alpha val="35000"/>
-              </a:srgbClr>
-            </a:outerShdw>
-          </a:effectLst>
-        </a:effectStyle>
-        <a:effectStyle>
-          <a:effectLst>
-            <a:outerShdw blurRad="40000" dist="23000" dir="5400000" rotWithShape="0">
-              <a:srgbClr val="000000">
-                <a:alpha val="35000"/>
-              </a:srgbClr>
-            </a:outerShdw>
-          </a:effectLst>
-          <a:scene3d>
-            <a:camera prst="orthographicFront">
-              <a:rot lat="0" lon="0" rev="0"/>
-            </a:camera>
-            <a:lightRig rig="threePt" dir="t">
-              <a:rot lat="0" lon="0" rev="1200000"/>
-            </a:lightRig>
-          </a:scene3d>
-          <a:sp3d>
-            <a:bevelT w="63500" h="25400"/>
-          </a:sp3d>
         </a:effectStyle>
       </a:effectStyleLst>
       <a:bgFillStyleLst>
         <a:solidFill>
           <a:schemeClr val="phClr"/>
         </a:solidFill>
+        <a:solidFill>
+          <a:schemeClr val="phClr">
+            <a:tint val="95000"/>
+            <a:satMod val="170000"/>
+          </a:schemeClr>
+        </a:solidFill>
         <a:gradFill rotWithShape="1">
           <a:gsLst>
             <a:gs pos="0">
               <a:schemeClr val="phClr">
-                <a:tint val="40000"/>
-                <a:satMod val="350000"/>
+                <a:tint val="93000"/>
+                <a:satMod val="150000"/>
+                <a:shade val="98000"/>
+                <a:lumMod val="102000"/>
               </a:schemeClr>
             </a:gs>
-            <a:gs pos="40000">
+            <a:gs pos="50000">
               <a:schemeClr val="phClr">
-                <a:tint val="45000"/>
-                <a:shade val="99000"/>
-                <a:satMod val="350000"/>
+                <a:tint val="98000"/>
+                <a:satMod val="130000"/>
+                <a:shade val="90000"/>
+                <a:lumMod val="103000"/>
               </a:schemeClr>
             </a:gs>
             <a:gs pos="100000">
               <a:schemeClr val="phClr">
-                <a:shade val="20000"/>
-                <a:satMod val="255000"/>
+                <a:shade val="63000"/>
+                <a:satMod val="120000"/>
               </a:schemeClr>
             </a:gs>
           </a:gsLst>
-          <a:path path="circle">
-            <a:fillToRect l="50000" t="-80000" r="50000" b="180000"/>
-          </a:path>
-        </a:gradFill>
-        <a:gradFill rotWithShape="1">
-          <a:gsLst>
-            <a:gs pos="0">
-              <a:schemeClr val="phClr">
-                <a:tint val="80000"/>
-                <a:satMod val="300000"/>
-              </a:schemeClr>
-            </a:gs>
-            <a:gs pos="100000">
-              <a:schemeClr val="phClr">
-                <a:shade val="30000"/>
-                <a:satMod val="200000"/>
-              </a:schemeClr>
-            </a:gs>
-          </a:gsLst>
-          <a:path path="circle">
-            <a:fillToRect l="50000" t="50000" r="50000" b="50000"/>
-          </a:path>
+          <a:lin ang="5400000" scaled="0"/>
         </a:gradFill>
       </a:bgFillStyleLst>
     </a:fmtScheme>
   </a:themeElements>
   <a:objectDefaults/>
   <a:extraClrSchemeLst/>
+  <a:extLst>
+    <a:ext uri="{05A4C25C-085E-4340-85A3-A5531E510DB2}">
+      <thm15:themeFamily xmlns:thm15="http://schemas.microsoft.com/office/thememl/2012/main" name="Presentation1" id="{332E3885-27C7-437A-AD98-DBAA83906A3B}" vid="{03C5CB92-4D50-43E4-82CF-5FD8DE4F2C52}"/>
+    </a:ext>
+  </a:extLst>
 </a:theme>
 </file>
</xml_diff>